<commit_message>
changes in .pptx presentation
</commit_message>
<xml_diff>
--- a/docs/BotWork_Application.pptx
+++ b/docs/BotWork_Application.pptx
@@ -5,23 +5,23 @@
     <p:sldMasterId id="2147483648" r:id="rId1"/>
   </p:sldMasterIdLst>
   <p:sldIdLst>
-    <p:sldId id="256" r:id="rId7"/>
-    <p:sldId id="257" r:id="rId8"/>
-    <p:sldId id="258" r:id="rId9"/>
-    <p:sldId id="259" r:id="rId10"/>
-    <p:sldId id="260" r:id="rId11"/>
-    <p:sldId id="261" r:id="rId12"/>
-    <p:sldId id="262" r:id="rId13"/>
-    <p:sldId id="263" r:id="rId14"/>
-    <p:sldId id="264" r:id="rId15"/>
-    <p:sldId id="265" r:id="rId16"/>
-    <p:sldId id="266" r:id="rId17"/>
-    <p:sldId id="267" r:id="rId18"/>
-    <p:sldId id="268" r:id="rId19"/>
-    <p:sldId id="269" r:id="rId20"/>
-    <p:sldId id="270" r:id="rId21"/>
-    <p:sldId id="271" r:id="rId22"/>
-    <p:sldId id="272" r:id="rId23"/>
+    <p:sldId id="256" r:id="rId2"/>
+    <p:sldId id="257" r:id="rId3"/>
+    <p:sldId id="258" r:id="rId4"/>
+    <p:sldId id="259" r:id="rId5"/>
+    <p:sldId id="260" r:id="rId6"/>
+    <p:sldId id="261" r:id="rId7"/>
+    <p:sldId id="262" r:id="rId8"/>
+    <p:sldId id="263" r:id="rId9"/>
+    <p:sldId id="264" r:id="rId10"/>
+    <p:sldId id="265" r:id="rId11"/>
+    <p:sldId id="266" r:id="rId12"/>
+    <p:sldId id="267" r:id="rId13"/>
+    <p:sldId id="268" r:id="rId14"/>
+    <p:sldId id="269" r:id="rId15"/>
+    <p:sldId id="270" r:id="rId16"/>
+    <p:sldId id="271" r:id="rId17"/>
+    <p:sldId id="272" r:id="rId18"/>
   </p:sldIdLst>
   <p:sldSz cx="9144000" cy="6858000" type="screen4x3"/>
   <p:notesSz cx="6858000" cy="9144000"/>
@@ -120,6 +120,22 @@
       </a:defRPr>
     </a:lvl9pPr>
   </p:defaultTextStyle>
+  <p:extLst>
+    <p:ext uri="{EFAFB233-063F-42B5-8137-9DF3F51BA10A}">
+      <p15:sldGuideLst xmlns:p15="http://schemas.microsoft.com/office/powerpoint/2012/main">
+        <p15:guide id="1" orient="horz" pos="2160">
+          <p15:clr>
+            <a:srgbClr val="A4A3A4"/>
+          </p15:clr>
+        </p15:guide>
+        <p15:guide id="2" pos="2880">
+          <p15:clr>
+            <a:srgbClr val="A4A3A4"/>
+          </p15:clr>
+        </p15:guide>
+      </p15:sldGuideLst>
+    </p:ext>
+  </p:extLst>
 </p:presentation>
 </file>
 
@@ -161,10 +177,9 @@
           <a:lstStyle/>
           <a:p>
             <a:r>
-              <a:rPr lang="en-US" smtClean="0"/>
+              <a:rPr lang="en-US"/>
               <a:t>Click to edit Master title style</a:t>
             </a:r>
-            <a:endParaRPr lang="en-US"/>
           </a:p>
         </p:txBody>
       </p:sp>
@@ -280,10 +295,9 @@
           </a:lstStyle>
           <a:p>
             <a:r>
-              <a:rPr lang="en-US" smtClean="0"/>
+              <a:rPr lang="en-US"/>
               <a:t>Click to edit Master subtitle style</a:t>
             </a:r>
-            <a:endParaRPr lang="en-US"/>
           </a:p>
         </p:txBody>
       </p:sp>
@@ -304,7 +318,7 @@
           <a:p>
             <a:fld id="{5BCAD085-E8A6-8845-BD4E-CB4CCA059FC4}" type="datetimeFigureOut">
               <a:rPr lang="en-US" smtClean="0"/>
-              <a:t>1/27/13</a:t>
+              <a:t>3/10/26</a:t>
             </a:fld>
             <a:endParaRPr lang="en-US"/>
           </a:p>
@@ -398,10 +412,9 @@
           <a:lstStyle/>
           <a:p>
             <a:r>
-              <a:rPr lang="en-US" smtClean="0"/>
+              <a:rPr lang="en-US"/>
               <a:t>Click to edit Master title style</a:t>
             </a:r>
-            <a:endParaRPr lang="en-US"/>
           </a:p>
         </p:txBody>
       </p:sp>
@@ -422,38 +435,37 @@
           <a:p>
             <a:pPr lvl="0"/>
             <a:r>
-              <a:rPr lang="en-US" smtClean="0"/>
+              <a:rPr lang="en-US"/>
               <a:t>Click to edit Master text styles</a:t>
             </a:r>
           </a:p>
           <a:p>
             <a:pPr lvl="1"/>
             <a:r>
-              <a:rPr lang="en-US" smtClean="0"/>
+              <a:rPr lang="en-US"/>
               <a:t>Second level</a:t>
             </a:r>
           </a:p>
           <a:p>
             <a:pPr lvl="2"/>
             <a:r>
-              <a:rPr lang="en-US" smtClean="0"/>
+              <a:rPr lang="en-US"/>
               <a:t>Third level</a:t>
             </a:r>
           </a:p>
           <a:p>
             <a:pPr lvl="3"/>
             <a:r>
-              <a:rPr lang="en-US" smtClean="0"/>
+              <a:rPr lang="en-US"/>
               <a:t>Fourth level</a:t>
             </a:r>
           </a:p>
           <a:p>
             <a:pPr lvl="4"/>
             <a:r>
-              <a:rPr lang="en-US" smtClean="0"/>
+              <a:rPr lang="en-US"/>
               <a:t>Fifth level</a:t>
             </a:r>
-            <a:endParaRPr lang="en-US"/>
           </a:p>
         </p:txBody>
       </p:sp>
@@ -474,7 +486,7 @@
           <a:p>
             <a:fld id="{5BCAD085-E8A6-8845-BD4E-CB4CCA059FC4}" type="datetimeFigureOut">
               <a:rPr lang="en-US" smtClean="0"/>
-              <a:t>1/27/13</a:t>
+              <a:t>3/10/26</a:t>
             </a:fld>
             <a:endParaRPr lang="en-US"/>
           </a:p>
@@ -573,10 +585,9 @@
           <a:lstStyle/>
           <a:p>
             <a:r>
-              <a:rPr lang="en-US" smtClean="0"/>
+              <a:rPr lang="en-US"/>
               <a:t>Click to edit Master title style</a:t>
             </a:r>
-            <a:endParaRPr lang="en-US"/>
           </a:p>
         </p:txBody>
       </p:sp>
@@ -602,38 +613,37 @@
           <a:p>
             <a:pPr lvl="0"/>
             <a:r>
-              <a:rPr lang="en-US" smtClean="0"/>
+              <a:rPr lang="en-US"/>
               <a:t>Click to edit Master text styles</a:t>
             </a:r>
           </a:p>
           <a:p>
             <a:pPr lvl="1"/>
             <a:r>
-              <a:rPr lang="en-US" smtClean="0"/>
+              <a:rPr lang="en-US"/>
               <a:t>Second level</a:t>
             </a:r>
           </a:p>
           <a:p>
             <a:pPr lvl="2"/>
             <a:r>
-              <a:rPr lang="en-US" smtClean="0"/>
+              <a:rPr lang="en-US"/>
               <a:t>Third level</a:t>
             </a:r>
           </a:p>
           <a:p>
             <a:pPr lvl="3"/>
             <a:r>
-              <a:rPr lang="en-US" smtClean="0"/>
+              <a:rPr lang="en-US"/>
               <a:t>Fourth level</a:t>
             </a:r>
           </a:p>
           <a:p>
             <a:pPr lvl="4"/>
             <a:r>
-              <a:rPr lang="en-US" smtClean="0"/>
+              <a:rPr lang="en-US"/>
               <a:t>Fifth level</a:t>
             </a:r>
-            <a:endParaRPr lang="en-US"/>
           </a:p>
         </p:txBody>
       </p:sp>
@@ -654,7 +664,7 @@
           <a:p>
             <a:fld id="{5BCAD085-E8A6-8845-BD4E-CB4CCA059FC4}" type="datetimeFigureOut">
               <a:rPr lang="en-US" smtClean="0"/>
-              <a:t>1/27/13</a:t>
+              <a:t>3/10/26</a:t>
             </a:fld>
             <a:endParaRPr lang="en-US"/>
           </a:p>
@@ -748,10 +758,9 @@
           <a:lstStyle/>
           <a:p>
             <a:r>
-              <a:rPr lang="en-US" smtClean="0"/>
+              <a:rPr lang="en-US"/>
               <a:t>Click to edit Master title style</a:t>
             </a:r>
-            <a:endParaRPr lang="en-US"/>
           </a:p>
         </p:txBody>
       </p:sp>
@@ -772,38 +781,37 @@
           <a:p>
             <a:pPr lvl="0"/>
             <a:r>
-              <a:rPr lang="en-US" smtClean="0"/>
+              <a:rPr lang="en-US"/>
               <a:t>Click to edit Master text styles</a:t>
             </a:r>
           </a:p>
           <a:p>
             <a:pPr lvl="1"/>
             <a:r>
-              <a:rPr lang="en-US" smtClean="0"/>
+              <a:rPr lang="en-US"/>
               <a:t>Second level</a:t>
             </a:r>
           </a:p>
           <a:p>
             <a:pPr lvl="2"/>
             <a:r>
-              <a:rPr lang="en-US" smtClean="0"/>
+              <a:rPr lang="en-US"/>
               <a:t>Third level</a:t>
             </a:r>
           </a:p>
           <a:p>
             <a:pPr lvl="3"/>
             <a:r>
-              <a:rPr lang="en-US" smtClean="0"/>
+              <a:rPr lang="en-US"/>
               <a:t>Fourth level</a:t>
             </a:r>
           </a:p>
           <a:p>
             <a:pPr lvl="4"/>
             <a:r>
-              <a:rPr lang="en-US" smtClean="0"/>
+              <a:rPr lang="en-US"/>
               <a:t>Fifth level</a:t>
             </a:r>
-            <a:endParaRPr lang="en-US"/>
           </a:p>
         </p:txBody>
       </p:sp>
@@ -824,7 +832,7 @@
           <a:p>
             <a:fld id="{5BCAD085-E8A6-8845-BD4E-CB4CCA059FC4}" type="datetimeFigureOut">
               <a:rPr lang="en-US" smtClean="0"/>
-              <a:t>1/27/13</a:t>
+              <a:t>3/10/26</a:t>
             </a:fld>
             <a:endParaRPr lang="en-US"/>
           </a:p>
@@ -927,10 +935,9 @@
           </a:lstStyle>
           <a:p>
             <a:r>
-              <a:rPr lang="en-US" smtClean="0"/>
+              <a:rPr lang="en-US"/>
               <a:t>Click to edit Master title style</a:t>
             </a:r>
-            <a:endParaRPr lang="en-US"/>
           </a:p>
         </p:txBody>
       </p:sp>
@@ -1047,7 +1054,7 @@
           <a:p>
             <a:pPr lvl="0"/>
             <a:r>
-              <a:rPr lang="en-US" smtClean="0"/>
+              <a:rPr lang="en-US"/>
               <a:t>Click to edit Master text styles</a:t>
             </a:r>
           </a:p>
@@ -1070,7 +1077,7 @@
           <a:p>
             <a:fld id="{5BCAD085-E8A6-8845-BD4E-CB4CCA059FC4}" type="datetimeFigureOut">
               <a:rPr lang="en-US" smtClean="0"/>
-              <a:t>1/27/13</a:t>
+              <a:t>3/10/26</a:t>
             </a:fld>
             <a:endParaRPr lang="en-US"/>
           </a:p>
@@ -1164,10 +1171,9 @@
           <a:lstStyle/>
           <a:p>
             <a:r>
-              <a:rPr lang="en-US" smtClean="0"/>
+              <a:rPr lang="en-US"/>
               <a:t>Click to edit Master title style</a:t>
             </a:r>
-            <a:endParaRPr lang="en-US"/>
           </a:p>
         </p:txBody>
       </p:sp>
@@ -1221,38 +1227,37 @@
           <a:p>
             <a:pPr lvl="0"/>
             <a:r>
-              <a:rPr lang="en-US" smtClean="0"/>
+              <a:rPr lang="en-US"/>
               <a:t>Click to edit Master text styles</a:t>
             </a:r>
           </a:p>
           <a:p>
             <a:pPr lvl="1"/>
             <a:r>
-              <a:rPr lang="en-US" smtClean="0"/>
+              <a:rPr lang="en-US"/>
               <a:t>Second level</a:t>
             </a:r>
           </a:p>
           <a:p>
             <a:pPr lvl="2"/>
             <a:r>
-              <a:rPr lang="en-US" smtClean="0"/>
+              <a:rPr lang="en-US"/>
               <a:t>Third level</a:t>
             </a:r>
           </a:p>
           <a:p>
             <a:pPr lvl="3"/>
             <a:r>
-              <a:rPr lang="en-US" smtClean="0"/>
+              <a:rPr lang="en-US"/>
               <a:t>Fourth level</a:t>
             </a:r>
           </a:p>
           <a:p>
             <a:pPr lvl="4"/>
             <a:r>
-              <a:rPr lang="en-US" smtClean="0"/>
+              <a:rPr lang="en-US"/>
               <a:t>Fifth level</a:t>
             </a:r>
-            <a:endParaRPr lang="en-US"/>
           </a:p>
         </p:txBody>
       </p:sp>
@@ -1306,38 +1311,37 @@
           <a:p>
             <a:pPr lvl="0"/>
             <a:r>
-              <a:rPr lang="en-US" smtClean="0"/>
+              <a:rPr lang="en-US"/>
               <a:t>Click to edit Master text styles</a:t>
             </a:r>
           </a:p>
           <a:p>
             <a:pPr lvl="1"/>
             <a:r>
-              <a:rPr lang="en-US" smtClean="0"/>
+              <a:rPr lang="en-US"/>
               <a:t>Second level</a:t>
             </a:r>
           </a:p>
           <a:p>
             <a:pPr lvl="2"/>
             <a:r>
-              <a:rPr lang="en-US" smtClean="0"/>
+              <a:rPr lang="en-US"/>
               <a:t>Third level</a:t>
             </a:r>
           </a:p>
           <a:p>
             <a:pPr lvl="3"/>
             <a:r>
-              <a:rPr lang="en-US" smtClean="0"/>
+              <a:rPr lang="en-US"/>
               <a:t>Fourth level</a:t>
             </a:r>
           </a:p>
           <a:p>
             <a:pPr lvl="4"/>
             <a:r>
-              <a:rPr lang="en-US" smtClean="0"/>
+              <a:rPr lang="en-US"/>
               <a:t>Fifth level</a:t>
             </a:r>
-            <a:endParaRPr lang="en-US"/>
           </a:p>
         </p:txBody>
       </p:sp>
@@ -1358,7 +1362,7 @@
           <a:p>
             <a:fld id="{5BCAD085-E8A6-8845-BD4E-CB4CCA059FC4}" type="datetimeFigureOut">
               <a:rPr lang="en-US" smtClean="0"/>
-              <a:t>1/27/13</a:t>
+              <a:t>3/10/26</a:t>
             </a:fld>
             <a:endParaRPr lang="en-US"/>
           </a:p>
@@ -1456,10 +1460,9 @@
           </a:lstStyle>
           <a:p>
             <a:r>
-              <a:rPr lang="en-US" smtClean="0"/>
+              <a:rPr lang="en-US"/>
               <a:t>Click to edit Master title style</a:t>
             </a:r>
-            <a:endParaRPr lang="en-US"/>
           </a:p>
         </p:txBody>
       </p:sp>
@@ -1522,7 +1525,7 @@
           <a:p>
             <a:pPr lvl="0"/>
             <a:r>
-              <a:rPr lang="en-US" smtClean="0"/>
+              <a:rPr lang="en-US"/>
               <a:t>Click to edit Master text styles</a:t>
             </a:r>
           </a:p>
@@ -1578,38 +1581,37 @@
           <a:p>
             <a:pPr lvl="0"/>
             <a:r>
-              <a:rPr lang="en-US" smtClean="0"/>
+              <a:rPr lang="en-US"/>
               <a:t>Click to edit Master text styles</a:t>
             </a:r>
           </a:p>
           <a:p>
             <a:pPr lvl="1"/>
             <a:r>
-              <a:rPr lang="en-US" smtClean="0"/>
+              <a:rPr lang="en-US"/>
               <a:t>Second level</a:t>
             </a:r>
           </a:p>
           <a:p>
             <a:pPr lvl="2"/>
             <a:r>
-              <a:rPr lang="en-US" smtClean="0"/>
+              <a:rPr lang="en-US"/>
               <a:t>Third level</a:t>
             </a:r>
           </a:p>
           <a:p>
             <a:pPr lvl="3"/>
             <a:r>
-              <a:rPr lang="en-US" smtClean="0"/>
+              <a:rPr lang="en-US"/>
               <a:t>Fourth level</a:t>
             </a:r>
           </a:p>
           <a:p>
             <a:pPr lvl="4"/>
             <a:r>
-              <a:rPr lang="en-US" smtClean="0"/>
+              <a:rPr lang="en-US"/>
               <a:t>Fifth level</a:t>
             </a:r>
-            <a:endParaRPr lang="en-US"/>
           </a:p>
         </p:txBody>
       </p:sp>
@@ -1672,7 +1674,7 @@
           <a:p>
             <a:pPr lvl="0"/>
             <a:r>
-              <a:rPr lang="en-US" smtClean="0"/>
+              <a:rPr lang="en-US"/>
               <a:t>Click to edit Master text styles</a:t>
             </a:r>
           </a:p>
@@ -1728,38 +1730,37 @@
           <a:p>
             <a:pPr lvl="0"/>
             <a:r>
-              <a:rPr lang="en-US" smtClean="0"/>
+              <a:rPr lang="en-US"/>
               <a:t>Click to edit Master text styles</a:t>
             </a:r>
           </a:p>
           <a:p>
             <a:pPr lvl="1"/>
             <a:r>
-              <a:rPr lang="en-US" smtClean="0"/>
+              <a:rPr lang="en-US"/>
               <a:t>Second level</a:t>
             </a:r>
           </a:p>
           <a:p>
             <a:pPr lvl="2"/>
             <a:r>
-              <a:rPr lang="en-US" smtClean="0"/>
+              <a:rPr lang="en-US"/>
               <a:t>Third level</a:t>
             </a:r>
           </a:p>
           <a:p>
             <a:pPr lvl="3"/>
             <a:r>
-              <a:rPr lang="en-US" smtClean="0"/>
+              <a:rPr lang="en-US"/>
               <a:t>Fourth level</a:t>
             </a:r>
           </a:p>
           <a:p>
             <a:pPr lvl="4"/>
             <a:r>
-              <a:rPr lang="en-US" smtClean="0"/>
+              <a:rPr lang="en-US"/>
               <a:t>Fifth level</a:t>
             </a:r>
-            <a:endParaRPr lang="en-US"/>
           </a:p>
         </p:txBody>
       </p:sp>
@@ -1780,7 +1781,7 @@
           <a:p>
             <a:fld id="{5BCAD085-E8A6-8845-BD4E-CB4CCA059FC4}" type="datetimeFigureOut">
               <a:rPr lang="en-US" smtClean="0"/>
-              <a:t>1/27/13</a:t>
+              <a:t>3/10/26</a:t>
             </a:fld>
             <a:endParaRPr lang="en-US"/>
           </a:p>
@@ -1874,10 +1875,9 @@
           <a:lstStyle/>
           <a:p>
             <a:r>
-              <a:rPr lang="en-US" smtClean="0"/>
+              <a:rPr lang="en-US"/>
               <a:t>Click to edit Master title style</a:t>
             </a:r>
-            <a:endParaRPr lang="en-US"/>
           </a:p>
         </p:txBody>
       </p:sp>
@@ -1898,7 +1898,7 @@
           <a:p>
             <a:fld id="{5BCAD085-E8A6-8845-BD4E-CB4CCA059FC4}" type="datetimeFigureOut">
               <a:rPr lang="en-US" smtClean="0"/>
-              <a:t>1/27/13</a:t>
+              <a:t>3/10/26</a:t>
             </a:fld>
             <a:endParaRPr lang="en-US"/>
           </a:p>
@@ -1993,7 +1993,7 @@
           <a:p>
             <a:fld id="{5BCAD085-E8A6-8845-BD4E-CB4CCA059FC4}" type="datetimeFigureOut">
               <a:rPr lang="en-US" smtClean="0"/>
-              <a:t>1/27/13</a:t>
+              <a:t>3/10/26</a:t>
             </a:fld>
             <a:endParaRPr lang="en-US"/>
           </a:p>
@@ -2096,10 +2096,9 @@
           </a:lstStyle>
           <a:p>
             <a:r>
-              <a:rPr lang="en-US" smtClean="0"/>
+              <a:rPr lang="en-US"/>
               <a:t>Click to edit Master title style</a:t>
             </a:r>
-            <a:endParaRPr lang="en-US"/>
           </a:p>
         </p:txBody>
       </p:sp>
@@ -2153,38 +2152,37 @@
           <a:p>
             <a:pPr lvl="0"/>
             <a:r>
-              <a:rPr lang="en-US" smtClean="0"/>
+              <a:rPr lang="en-US"/>
               <a:t>Click to edit Master text styles</a:t>
             </a:r>
           </a:p>
           <a:p>
             <a:pPr lvl="1"/>
             <a:r>
-              <a:rPr lang="en-US" smtClean="0"/>
+              <a:rPr lang="en-US"/>
               <a:t>Second level</a:t>
             </a:r>
           </a:p>
           <a:p>
             <a:pPr lvl="2"/>
             <a:r>
-              <a:rPr lang="en-US" smtClean="0"/>
+              <a:rPr lang="en-US"/>
               <a:t>Third level</a:t>
             </a:r>
           </a:p>
           <a:p>
             <a:pPr lvl="3"/>
             <a:r>
-              <a:rPr lang="en-US" smtClean="0"/>
+              <a:rPr lang="en-US"/>
               <a:t>Fourth level</a:t>
             </a:r>
           </a:p>
           <a:p>
             <a:pPr lvl="4"/>
             <a:r>
-              <a:rPr lang="en-US" smtClean="0"/>
+              <a:rPr lang="en-US"/>
               <a:t>Fifth level</a:t>
             </a:r>
-            <a:endParaRPr lang="en-US"/>
           </a:p>
         </p:txBody>
       </p:sp>
@@ -2247,7 +2245,7 @@
           <a:p>
             <a:pPr lvl="0"/>
             <a:r>
-              <a:rPr lang="en-US" smtClean="0"/>
+              <a:rPr lang="en-US"/>
               <a:t>Click to edit Master text styles</a:t>
             </a:r>
           </a:p>
@@ -2270,7 +2268,7 @@
           <a:p>
             <a:fld id="{5BCAD085-E8A6-8845-BD4E-CB4CCA059FC4}" type="datetimeFigureOut">
               <a:rPr lang="en-US" smtClean="0"/>
-              <a:t>1/27/13</a:t>
+              <a:t>3/10/26</a:t>
             </a:fld>
             <a:endParaRPr lang="en-US"/>
           </a:p>
@@ -2373,10 +2371,9 @@
           </a:lstStyle>
           <a:p>
             <a:r>
-              <a:rPr lang="en-US" smtClean="0"/>
+              <a:rPr lang="en-US"/>
               <a:t>Click to edit Master title style</a:t>
             </a:r>
-            <a:endParaRPr lang="en-US"/>
           </a:p>
         </p:txBody>
       </p:sp>
@@ -2500,7 +2497,7 @@
           <a:p>
             <a:pPr lvl="0"/>
             <a:r>
-              <a:rPr lang="en-US" smtClean="0"/>
+              <a:rPr lang="en-US"/>
               <a:t>Click to edit Master text styles</a:t>
             </a:r>
           </a:p>
@@ -2523,7 +2520,7 @@
           <a:p>
             <a:fld id="{5BCAD085-E8A6-8845-BD4E-CB4CCA059FC4}" type="datetimeFigureOut">
               <a:rPr lang="en-US" smtClean="0"/>
-              <a:t>1/27/13</a:t>
+              <a:t>3/10/26</a:t>
             </a:fld>
             <a:endParaRPr lang="en-US"/>
           </a:p>
@@ -2632,10 +2629,9 @@
           <a:lstStyle/>
           <a:p>
             <a:r>
-              <a:rPr lang="en-US" smtClean="0"/>
+              <a:rPr lang="en-US"/>
               <a:t>Click to edit Master title style</a:t>
             </a:r>
-            <a:endParaRPr lang="en-US"/>
           </a:p>
         </p:txBody>
       </p:sp>
@@ -2666,38 +2662,37 @@
           <a:p>
             <a:pPr lvl="0"/>
             <a:r>
-              <a:rPr lang="en-US" smtClean="0"/>
+              <a:rPr lang="en-US"/>
               <a:t>Click to edit Master text styles</a:t>
             </a:r>
           </a:p>
           <a:p>
             <a:pPr lvl="1"/>
             <a:r>
-              <a:rPr lang="en-US" smtClean="0"/>
+              <a:rPr lang="en-US"/>
               <a:t>Second level</a:t>
             </a:r>
           </a:p>
           <a:p>
             <a:pPr lvl="2"/>
             <a:r>
-              <a:rPr lang="en-US" smtClean="0"/>
+              <a:rPr lang="en-US"/>
               <a:t>Third level</a:t>
             </a:r>
           </a:p>
           <a:p>
             <a:pPr lvl="3"/>
             <a:r>
-              <a:rPr lang="en-US" smtClean="0"/>
+              <a:rPr lang="en-US"/>
               <a:t>Fourth level</a:t>
             </a:r>
           </a:p>
           <a:p>
             <a:pPr lvl="4"/>
             <a:r>
-              <a:rPr lang="en-US" smtClean="0"/>
+              <a:rPr lang="en-US"/>
               <a:t>Fifth level</a:t>
             </a:r>
-            <a:endParaRPr lang="en-US"/>
           </a:p>
         </p:txBody>
       </p:sp>
@@ -2736,7 +2731,7 @@
           <a:p>
             <a:fld id="{5BCAD085-E8A6-8845-BD4E-CB4CCA059FC4}" type="datetimeFigureOut">
               <a:rPr lang="en-US" smtClean="0"/>
-              <a:t>1/27/13</a:t>
+              <a:t>3/10/26</a:t>
             </a:fld>
             <a:endParaRPr lang="en-US"/>
           </a:p>
@@ -3095,7 +3090,7 @@
 </file>
 
 <file path=ppt/slides/slide1.xml><?xml version="1.0" encoding="utf-8"?>
-<p:sld xmlns:a="http://schemas.openxmlformats.org/drawingml/2006/main" xmlns:p="http://schemas.openxmlformats.org/presentationml/2006/main" xmlns:r="http://schemas.openxmlformats.org/officeDocument/2006/relationships">
+<p:sld xmlns:a="http://schemas.openxmlformats.org/drawingml/2006/main" xmlns:r="http://schemas.openxmlformats.org/officeDocument/2006/relationships" xmlns:p="http://schemas.openxmlformats.org/presentationml/2006/main">
   <p:cSld>
     <p:bg>
       <p:bgPr>
@@ -3111,7 +3106,14 @@
         <p:cNvGrpSpPr/>
         <p:nvPr/>
       </p:nvGrpSpPr>
-      <p:grpSpPr/>
+      <p:grpSpPr>
+        <a:xfrm>
+          <a:off x="0" y="0"/>
+          <a:ext cx="0" cy="0"/>
+          <a:chOff x="0" y="0"/>
+          <a:chExt cx="0" cy="0"/>
+        </a:xfrm>
+      </p:grpSpPr>
       <p:sp>
         <p:nvSpPr>
           <p:cNvPr id="2" name="Rectangle 1"/>
@@ -3152,6 +3154,7 @@
           <a:lstStyle/>
           <a:p>
             <a:pPr algn="ctr"/>
+            <a:endParaRPr/>
           </a:p>
         </p:txBody>
       </p:sp>
@@ -3195,6 +3198,7 @@
           <a:lstStyle/>
           <a:p>
             <a:pPr algn="ctr"/>
+            <a:endParaRPr/>
           </a:p>
         </p:txBody>
       </p:sp>
@@ -3238,6 +3242,7 @@
           <a:lstStyle/>
           <a:p>
             <a:pPr algn="ctr"/>
+            <a:endParaRPr/>
           </a:p>
         </p:txBody>
       </p:sp>
@@ -3281,6 +3286,7 @@
           <a:lstStyle/>
           <a:p>
             <a:pPr algn="ctr"/>
+            <a:endParaRPr/>
           </a:p>
         </p:txBody>
       </p:sp>
@@ -3324,6 +3330,7 @@
           <a:lstStyle/>
           <a:p>
             <a:pPr algn="ctr"/>
+            <a:endParaRPr/>
           </a:p>
         </p:txBody>
       </p:sp>
@@ -3336,7 +3343,7 @@
         <p:spPr>
           <a:xfrm>
             <a:off x="800000" y="1200000"/>
-            <a:ext cx="5000000" cy="2500000"/>
+            <a:ext cx="5000000" cy="943848"/>
           </a:xfrm>
           <a:prstGeom prst="rect">
             <a:avLst/>
@@ -3361,8 +3368,10 @@
               </a:defRPr>
             </a:pPr>
             <a:r>
+              <a:rPr dirty="0" err="1"/>
               <a:t>BotWork</a:t>
             </a:r>
+            <a:endParaRPr dirty="0"/>
           </a:p>
           <a:p>
             <a:pPr algn="l">
@@ -3376,38 +3385,7 @@
                 <a:latin typeface="Georgia"/>
               </a:defRPr>
             </a:pPr>
-          </a:p>
-          <a:p>
-            <a:pPr algn="l">
-              <a:spcAft>
-                <a:spcPts val="400"/>
-              </a:spcAft>
-              <a:defRPr sz="2400" b="0">
-                <a:solidFill>
-                  <a:srgbClr val="1E1E1E"/>
-                </a:solidFill>
-                <a:latin typeface="Georgia"/>
-              </a:defRPr>
-            </a:pPr>
-            <a:r>
-              <a:t>Платформа для создания</a:t>
-            </a:r>
-          </a:p>
-          <a:p>
-            <a:pPr algn="l">
-              <a:spcAft>
-                <a:spcPts val="400"/>
-              </a:spcAft>
-              <a:defRPr sz="2400" b="0">
-                <a:solidFill>
-                  <a:srgbClr val="1E1E1E"/>
-                </a:solidFill>
-                <a:latin typeface="Georgia"/>
-              </a:defRPr>
-            </a:pPr>
-            <a:r>
-              <a:t>Telegram-ботов для бизнеса</a:t>
-            </a:r>
+            <a:endParaRPr dirty="0"/>
           </a:p>
         </p:txBody>
       </p:sp>
@@ -3420,7 +3398,7 @@
         <p:spPr>
           <a:xfrm>
             <a:off x="300000" y="4100000"/>
-            <a:ext cx="5000000" cy="2500000"/>
+            <a:ext cx="5000000" cy="1918474"/>
           </a:xfrm>
           <a:prstGeom prst="rect">
             <a:avLst/>
@@ -3433,49 +3411,141 @@
           </a:bodyPr>
           <a:lstStyle/>
           <a:p>
-            <a:pPr algn="l">
-              <a:spcAft>
-                <a:spcPts val="400"/>
-              </a:spcAft>
-              <a:defRPr sz="1600" b="0">
-                <a:solidFill>
-                  <a:srgbClr val="FFFFFF"/>
-                </a:solidFill>
-                <a:latin typeface="Georgia"/>
-              </a:defRPr>
-            </a:pPr>
-            <a:r>
-              <a:t>Номер заявки: ___________</a:t>
-            </a:r>
-          </a:p>
-          <a:p>
-            <a:pPr algn="l">
-              <a:spcAft>
-                <a:spcPts val="400"/>
-              </a:spcAft>
-              <a:defRPr sz="600" b="0">
-                <a:solidFill>
-                  <a:srgbClr val="1E1E1E"/>
-                </a:solidFill>
-                <a:latin typeface="Georgia"/>
-              </a:defRPr>
-            </a:pPr>
-          </a:p>
-          <a:p>
-            <a:pPr algn="l">
-              <a:spcAft>
-                <a:spcPts val="400"/>
-              </a:spcAft>
-              <a:defRPr sz="1600" b="0">
-                <a:solidFill>
-                  <a:srgbClr val="FFFFFF"/>
-                </a:solidFill>
-                <a:latin typeface="Georgia"/>
-              </a:defRPr>
-            </a:pPr>
-            <a:r>
-              <a:t>Заявитель: Репин Артемий, Мартынов Борис, Харисов Денис</a:t>
-            </a:r>
+            <a:pPr>
+              <a:spcAft>
+                <a:spcPts val="400"/>
+              </a:spcAft>
+              <a:defRPr sz="2400" b="0">
+                <a:solidFill>
+                  <a:srgbClr val="1E1E1E"/>
+                </a:solidFill>
+                <a:latin typeface="Georgia"/>
+              </a:defRPr>
+            </a:pPr>
+            <a:r>
+              <a:rPr lang="en-US" sz="1600" dirty="0"/>
+              <a:t>1. </a:t>
+            </a:r>
+            <a:r>
+              <a:rPr lang="ru-RU" sz="1600" dirty="0"/>
+              <a:t>Номер заявки</a:t>
+            </a:r>
+            <a:r>
+              <a:rPr lang="en-US" sz="1600" dirty="0"/>
+              <a:t>:</a:t>
+            </a:r>
+            <a:br>
+              <a:rPr lang="en-US" sz="1600" dirty="0"/>
+            </a:br>
+            <a:r>
+              <a:rPr lang="en-US" sz="1600" dirty="0"/>
+              <a:t>__________</a:t>
+            </a:r>
+            <a:br>
+              <a:rPr lang="en-US" sz="1600" dirty="0"/>
+            </a:br>
+            <a:r>
+              <a:rPr lang="en-US" sz="1600" dirty="0"/>
+              <a:t>2. </a:t>
+            </a:r>
+            <a:r>
+              <a:rPr lang="ru-RU" sz="1600" dirty="0"/>
+              <a:t>Проект</a:t>
+            </a:r>
+            <a:r>
+              <a:rPr lang="en-RU" sz="1600" dirty="0"/>
+              <a:t>:</a:t>
+            </a:r>
+            <a:br>
+              <a:rPr lang="en-RU" sz="1600" dirty="0"/>
+            </a:br>
+            <a:r>
+              <a:rPr lang="ru-RU" sz="1600" dirty="0"/>
+              <a:t>Платформа для создания</a:t>
+            </a:r>
+          </a:p>
+          <a:p>
+            <a:pPr>
+              <a:spcAft>
+                <a:spcPts val="400"/>
+              </a:spcAft>
+              <a:defRPr sz="2400" b="0">
+                <a:solidFill>
+                  <a:srgbClr val="1E1E1E"/>
+                </a:solidFill>
+                <a:latin typeface="Georgia"/>
+              </a:defRPr>
+            </a:pPr>
+            <a:r>
+              <a:rPr lang="en-GB" sz="1600" dirty="0"/>
+              <a:t>Telegram-</a:t>
+            </a:r>
+            <a:r>
+              <a:rPr lang="ru-RU" sz="1600" dirty="0"/>
+              <a:t>ботов для бизнеса</a:t>
+            </a:r>
+            <a:endParaRPr lang="en-US" sz="1600" dirty="0"/>
+          </a:p>
+          <a:p>
+            <a:pPr>
+              <a:spcAft>
+                <a:spcPts val="400"/>
+              </a:spcAft>
+              <a:defRPr sz="2400" b="0">
+                <a:solidFill>
+                  <a:srgbClr val="1E1E1E"/>
+                </a:solidFill>
+                <a:latin typeface="Georgia"/>
+              </a:defRPr>
+            </a:pPr>
+            <a:r>
+              <a:rPr lang="en-US" sz="1600" dirty="0"/>
+              <a:t>3. </a:t>
+            </a:r>
+            <a:r>
+              <a:rPr sz="1600" dirty="0" err="1"/>
+              <a:t>Заявитель</a:t>
+            </a:r>
+            <a:r>
+              <a:rPr sz="1600" dirty="0"/>
+              <a:t>: </a:t>
+            </a:r>
+            <a:br>
+              <a:rPr lang="en-US" sz="1600" dirty="0"/>
+            </a:br>
+            <a:r>
+              <a:rPr sz="1600" dirty="0"/>
+              <a:t>Репин Артемий, </a:t>
+            </a:r>
+            <a:r>
+              <a:rPr sz="1600" dirty="0" err="1"/>
+              <a:t>Мартынов</a:t>
+            </a:r>
+            <a:r>
+              <a:rPr sz="1600" dirty="0"/>
+              <a:t> </a:t>
+            </a:r>
+            <a:r>
+              <a:rPr sz="1600" dirty="0" err="1"/>
+              <a:t>Борис</a:t>
+            </a:r>
+            <a:r>
+              <a:rPr sz="1600" dirty="0"/>
+              <a:t>, </a:t>
+            </a:r>
+            <a:r>
+              <a:rPr sz="1600" dirty="0" err="1"/>
+              <a:t>Харисов</a:t>
+            </a:r>
+            <a:r>
+              <a:rPr sz="1600" dirty="0"/>
+              <a:t> </a:t>
+            </a:r>
+            <a:r>
+              <a:rPr sz="1600" dirty="0" err="1"/>
+              <a:t>Денис</a:t>
+            </a:r>
+            <a:endParaRPr sz="1600" dirty="0"/>
           </a:p>
         </p:txBody>
       </p:sp>
@@ -3515,7 +3585,7 @@
           </a:fontRef>
         </p:style>
         <p:txBody>
-          <a:bodyPr rtlCol="0" anchor="ctr" wrap="square"/>
+          <a:bodyPr wrap="square" rtlCol="0" anchor="ctr"/>
           <a:lstStyle/>
           <a:p>
             <a:pPr algn="ctr">
@@ -3568,7 +3638,7 @@
           </a:fontRef>
         </p:style>
         <p:txBody>
-          <a:bodyPr rtlCol="0" anchor="ctr" wrap="square"/>
+          <a:bodyPr wrap="square" rtlCol="0" anchor="ctr"/>
           <a:lstStyle/>
           <a:p>
             <a:pPr algn="ctr">
@@ -3642,7 +3712,7 @@
 </file>
 
 <file path=ppt/slides/slide10.xml><?xml version="1.0" encoding="utf-8"?>
-<p:sld xmlns:a="http://schemas.openxmlformats.org/drawingml/2006/main" xmlns:p="http://schemas.openxmlformats.org/presentationml/2006/main" xmlns:r="http://schemas.openxmlformats.org/officeDocument/2006/relationships">
+<p:sld xmlns:a="http://schemas.openxmlformats.org/drawingml/2006/main" xmlns:r="http://schemas.openxmlformats.org/officeDocument/2006/relationships" xmlns:p="http://schemas.openxmlformats.org/presentationml/2006/main">
   <p:cSld>
     <p:bg>
       <p:bgPr>
@@ -3658,7 +3728,14 @@
         <p:cNvGrpSpPr/>
         <p:nvPr/>
       </p:nvGrpSpPr>
-      <p:grpSpPr/>
+      <p:grpSpPr>
+        <a:xfrm>
+          <a:off x="0" y="0"/>
+          <a:ext cx="0" cy="0"/>
+          <a:chOff x="0" y="0"/>
+          <a:chExt cx="0" cy="0"/>
+        </a:xfrm>
+      </p:grpSpPr>
       <p:sp>
         <p:nvSpPr>
           <p:cNvPr id="2" name="Rectangle 1"/>
@@ -3695,7 +3772,7 @@
           </a:fontRef>
         </p:style>
         <p:txBody>
-          <a:bodyPr rtlCol="0" anchor="ctr" wrap="square"/>
+          <a:bodyPr wrap="square" rtlCol="0" anchor="ctr"/>
           <a:lstStyle/>
           <a:p>
             <a:pPr algn="l">
@@ -3752,6 +3829,7 @@
           <a:lstStyle/>
           <a:p>
             <a:pPr algn="ctr"/>
+            <a:endParaRPr/>
           </a:p>
         </p:txBody>
       </p:sp>
@@ -3795,6 +3873,7 @@
           <a:lstStyle/>
           <a:p>
             <a:pPr algn="ctr"/>
+            <a:endParaRPr/>
           </a:p>
         </p:txBody>
       </p:sp>
@@ -3838,6 +3917,7 @@
           <a:lstStyle/>
           <a:p>
             <a:pPr algn="ctr"/>
+            <a:endParaRPr/>
           </a:p>
         </p:txBody>
       </p:sp>
@@ -3881,6 +3961,7 @@
           <a:lstStyle/>
           <a:p>
             <a:pPr algn="ctr"/>
+            <a:endParaRPr/>
           </a:p>
         </p:txBody>
       </p:sp>
@@ -3924,6 +4005,7 @@
           <a:lstStyle/>
           <a:p>
             <a:pPr algn="ctr"/>
+            <a:endParaRPr/>
           </a:p>
         </p:txBody>
       </p:sp>
@@ -3976,6 +4058,7 @@
                 <a:latin typeface="Georgia"/>
               </a:defRPr>
             </a:pPr>
+            <a:endParaRPr/>
           </a:p>
           <a:p>
             <a:pPr algn="l">
@@ -4053,6 +4136,7 @@
                 <a:latin typeface="Georgia"/>
               </a:defRPr>
             </a:pPr>
+            <a:endParaRPr/>
           </a:p>
           <a:p>
             <a:pPr algn="l">
@@ -4114,6 +4198,7 @@
                 <a:latin typeface="Georgia"/>
               </a:defRPr>
             </a:pPr>
+            <a:endParaRPr/>
           </a:p>
           <a:p>
             <a:pPr algn="l">
@@ -4238,7 +4323,7 @@
 </file>
 
 <file path=ppt/slides/slide11.xml><?xml version="1.0" encoding="utf-8"?>
-<p:sld xmlns:a="http://schemas.openxmlformats.org/drawingml/2006/main" xmlns:p="http://schemas.openxmlformats.org/presentationml/2006/main" xmlns:r="http://schemas.openxmlformats.org/officeDocument/2006/relationships">
+<p:sld xmlns:a="http://schemas.openxmlformats.org/drawingml/2006/main" xmlns:r="http://schemas.openxmlformats.org/officeDocument/2006/relationships" xmlns:p="http://schemas.openxmlformats.org/presentationml/2006/main">
   <p:cSld>
     <p:bg>
       <p:bgPr>
@@ -4254,7 +4339,14 @@
         <p:cNvGrpSpPr/>
         <p:nvPr/>
       </p:nvGrpSpPr>
-      <p:grpSpPr/>
+      <p:grpSpPr>
+        <a:xfrm>
+          <a:off x="0" y="0"/>
+          <a:ext cx="0" cy="0"/>
+          <a:chOff x="0" y="0"/>
+          <a:chExt cx="0" cy="0"/>
+        </a:xfrm>
+      </p:grpSpPr>
       <p:sp>
         <p:nvSpPr>
           <p:cNvPr id="2" name="Rectangle 1"/>
@@ -4291,7 +4383,7 @@
           </a:fontRef>
         </p:style>
         <p:txBody>
-          <a:bodyPr rtlCol="0" anchor="ctr" wrap="square"/>
+          <a:bodyPr wrap="square" rtlCol="0" anchor="ctr"/>
           <a:lstStyle/>
           <a:p>
             <a:pPr algn="l">
@@ -4348,6 +4440,7 @@
           <a:lstStyle/>
           <a:p>
             <a:pPr algn="ctr"/>
+            <a:endParaRPr/>
           </a:p>
         </p:txBody>
       </p:sp>
@@ -4391,6 +4484,7 @@
           <a:lstStyle/>
           <a:p>
             <a:pPr algn="ctr"/>
+            <a:endParaRPr/>
           </a:p>
         </p:txBody>
       </p:sp>
@@ -4434,6 +4528,7 @@
           <a:lstStyle/>
           <a:p>
             <a:pPr algn="ctr"/>
+            <a:endParaRPr/>
           </a:p>
         </p:txBody>
       </p:sp>
@@ -4477,6 +4572,7 @@
           <a:lstStyle/>
           <a:p>
             <a:pPr algn="ctr"/>
+            <a:endParaRPr/>
           </a:p>
         </p:txBody>
       </p:sp>
@@ -4520,6 +4616,7 @@
           <a:lstStyle/>
           <a:p>
             <a:pPr algn="ctr"/>
+            <a:endParaRPr/>
           </a:p>
         </p:txBody>
       </p:sp>
@@ -4572,6 +4669,7 @@
                 <a:latin typeface="Georgia"/>
               </a:defRPr>
             </a:pPr>
+            <a:endParaRPr/>
           </a:p>
           <a:p>
             <a:pPr algn="l">
@@ -4601,6 +4699,7 @@
                 <a:latin typeface="Georgia"/>
               </a:defRPr>
             </a:pPr>
+            <a:endParaRPr/>
           </a:p>
           <a:p>
             <a:pPr algn="l">
@@ -4726,6 +4825,7 @@
                 <a:latin typeface="Georgia"/>
               </a:defRPr>
             </a:pPr>
+            <a:endParaRPr/>
           </a:p>
           <a:p>
             <a:pPr algn="l">
@@ -4802,7 +4902,7 @@
 </file>
 
 <file path=ppt/slides/slide12.xml><?xml version="1.0" encoding="utf-8"?>
-<p:sld xmlns:a="http://schemas.openxmlformats.org/drawingml/2006/main" xmlns:p="http://schemas.openxmlformats.org/presentationml/2006/main" xmlns:r="http://schemas.openxmlformats.org/officeDocument/2006/relationships">
+<p:sld xmlns:a="http://schemas.openxmlformats.org/drawingml/2006/main" xmlns:r="http://schemas.openxmlformats.org/officeDocument/2006/relationships" xmlns:p="http://schemas.openxmlformats.org/presentationml/2006/main">
   <p:cSld>
     <p:bg>
       <p:bgPr>
@@ -4818,7 +4918,14 @@
         <p:cNvGrpSpPr/>
         <p:nvPr/>
       </p:nvGrpSpPr>
-      <p:grpSpPr/>
+      <p:grpSpPr>
+        <a:xfrm>
+          <a:off x="0" y="0"/>
+          <a:ext cx="0" cy="0"/>
+          <a:chOff x="0" y="0"/>
+          <a:chExt cx="0" cy="0"/>
+        </a:xfrm>
+      </p:grpSpPr>
       <p:sp>
         <p:nvSpPr>
           <p:cNvPr id="2" name="Rectangle 1"/>
@@ -4855,7 +4962,7 @@
           </a:fontRef>
         </p:style>
         <p:txBody>
-          <a:bodyPr rtlCol="0" anchor="ctr" wrap="square"/>
+          <a:bodyPr wrap="square" rtlCol="0" anchor="ctr"/>
           <a:lstStyle/>
           <a:p>
             <a:pPr algn="l">
@@ -4912,6 +5019,7 @@
           <a:lstStyle/>
           <a:p>
             <a:pPr algn="ctr"/>
+            <a:endParaRPr/>
           </a:p>
         </p:txBody>
       </p:sp>
@@ -4955,6 +5063,7 @@
           <a:lstStyle/>
           <a:p>
             <a:pPr algn="ctr"/>
+            <a:endParaRPr/>
           </a:p>
         </p:txBody>
       </p:sp>
@@ -4998,6 +5107,7 @@
           <a:lstStyle/>
           <a:p>
             <a:pPr algn="ctr"/>
+            <a:endParaRPr/>
           </a:p>
         </p:txBody>
       </p:sp>
@@ -5041,6 +5151,7 @@
           <a:lstStyle/>
           <a:p>
             <a:pPr algn="ctr"/>
+            <a:endParaRPr/>
           </a:p>
         </p:txBody>
       </p:sp>
@@ -5084,6 +5195,7 @@
           <a:lstStyle/>
           <a:p>
             <a:pPr algn="ctr"/>
+            <a:endParaRPr/>
           </a:p>
         </p:txBody>
       </p:sp>
@@ -5136,6 +5248,7 @@
                 <a:latin typeface="Georgia"/>
               </a:defRPr>
             </a:pPr>
+            <a:endParaRPr/>
           </a:p>
           <a:p>
             <a:pPr algn="l">
@@ -5181,6 +5294,7 @@
                 <a:latin typeface="Georgia"/>
               </a:defRPr>
             </a:pPr>
+            <a:endParaRPr/>
           </a:p>
           <a:p>
             <a:pPr algn="l">
@@ -5226,6 +5340,7 @@
                 <a:latin typeface="Georgia"/>
               </a:defRPr>
             </a:pPr>
+            <a:endParaRPr/>
           </a:p>
           <a:p>
             <a:pPr algn="l">
@@ -5271,6 +5386,7 @@
                 <a:latin typeface="Georgia"/>
               </a:defRPr>
             </a:pPr>
+            <a:endParaRPr/>
           </a:p>
           <a:p>
             <a:pPr algn="l">
@@ -5316,6 +5432,7 @@
                 <a:latin typeface="Georgia"/>
               </a:defRPr>
             </a:pPr>
+            <a:endParaRPr/>
           </a:p>
           <a:p>
             <a:pPr algn="l">
@@ -5361,6 +5478,7 @@
                 <a:latin typeface="Georgia"/>
               </a:defRPr>
             </a:pPr>
+            <a:endParaRPr/>
           </a:p>
           <a:p>
             <a:pPr algn="l">
@@ -5437,7 +5555,7 @@
 </file>
 
 <file path=ppt/slides/slide13.xml><?xml version="1.0" encoding="utf-8"?>
-<p:sld xmlns:a="http://schemas.openxmlformats.org/drawingml/2006/main" xmlns:p="http://schemas.openxmlformats.org/presentationml/2006/main" xmlns:r="http://schemas.openxmlformats.org/officeDocument/2006/relationships">
+<p:sld xmlns:a="http://schemas.openxmlformats.org/drawingml/2006/main" xmlns:r="http://schemas.openxmlformats.org/officeDocument/2006/relationships" xmlns:p="http://schemas.openxmlformats.org/presentationml/2006/main">
   <p:cSld>
     <p:bg>
       <p:bgPr>
@@ -5453,7 +5571,14 @@
         <p:cNvGrpSpPr/>
         <p:nvPr/>
       </p:nvGrpSpPr>
-      <p:grpSpPr/>
+      <p:grpSpPr>
+        <a:xfrm>
+          <a:off x="0" y="0"/>
+          <a:ext cx="0" cy="0"/>
+          <a:chOff x="0" y="0"/>
+          <a:chExt cx="0" cy="0"/>
+        </a:xfrm>
+      </p:grpSpPr>
       <p:sp>
         <p:nvSpPr>
           <p:cNvPr id="2" name="Rectangle 1"/>
@@ -5490,7 +5615,7 @@
           </a:fontRef>
         </p:style>
         <p:txBody>
-          <a:bodyPr rtlCol="0" anchor="ctr" wrap="square"/>
+          <a:bodyPr wrap="square" rtlCol="0" anchor="ctr"/>
           <a:lstStyle/>
           <a:p>
             <a:pPr algn="l">
@@ -5547,6 +5672,7 @@
           <a:lstStyle/>
           <a:p>
             <a:pPr algn="ctr"/>
+            <a:endParaRPr/>
           </a:p>
         </p:txBody>
       </p:sp>
@@ -5590,6 +5716,7 @@
           <a:lstStyle/>
           <a:p>
             <a:pPr algn="ctr"/>
+            <a:endParaRPr/>
           </a:p>
         </p:txBody>
       </p:sp>
@@ -5633,6 +5760,7 @@
           <a:lstStyle/>
           <a:p>
             <a:pPr algn="ctr"/>
+            <a:endParaRPr/>
           </a:p>
         </p:txBody>
       </p:sp>
@@ -5676,6 +5804,7 @@
           <a:lstStyle/>
           <a:p>
             <a:pPr algn="ctr"/>
+            <a:endParaRPr/>
           </a:p>
         </p:txBody>
       </p:sp>
@@ -5719,6 +5848,7 @@
           <a:lstStyle/>
           <a:p>
             <a:pPr algn="ctr"/>
+            <a:endParaRPr/>
           </a:p>
         </p:txBody>
       </p:sp>
@@ -5771,6 +5901,7 @@
                 <a:latin typeface="Georgia"/>
               </a:defRPr>
             </a:pPr>
+            <a:endParaRPr/>
           </a:p>
           <a:p>
             <a:pPr algn="l">
@@ -5832,6 +5963,7 @@
                 <a:latin typeface="Georgia"/>
               </a:defRPr>
             </a:pPr>
+            <a:endParaRPr/>
           </a:p>
           <a:p>
             <a:pPr algn="l">
@@ -5893,6 +6025,7 @@
                 <a:latin typeface="Georgia"/>
               </a:defRPr>
             </a:pPr>
+            <a:endParaRPr/>
           </a:p>
           <a:p>
             <a:pPr algn="l">
@@ -5954,6 +6087,7 @@
                 <a:latin typeface="Georgia"/>
               </a:defRPr>
             </a:pPr>
+            <a:endParaRPr/>
           </a:p>
           <a:p>
             <a:pPr algn="l">
@@ -6046,7 +6180,7 @@
 </file>
 
 <file path=ppt/slides/slide14.xml><?xml version="1.0" encoding="utf-8"?>
-<p:sld xmlns:a="http://schemas.openxmlformats.org/drawingml/2006/main" xmlns:p="http://schemas.openxmlformats.org/presentationml/2006/main" xmlns:r="http://schemas.openxmlformats.org/officeDocument/2006/relationships">
+<p:sld xmlns:a="http://schemas.openxmlformats.org/drawingml/2006/main" xmlns:r="http://schemas.openxmlformats.org/officeDocument/2006/relationships" xmlns:p="http://schemas.openxmlformats.org/presentationml/2006/main">
   <p:cSld>
     <p:bg>
       <p:bgPr>
@@ -6062,7 +6196,14 @@
         <p:cNvGrpSpPr/>
         <p:nvPr/>
       </p:nvGrpSpPr>
-      <p:grpSpPr/>
+      <p:grpSpPr>
+        <a:xfrm>
+          <a:off x="0" y="0"/>
+          <a:ext cx="0" cy="0"/>
+          <a:chOff x="0" y="0"/>
+          <a:chExt cx="0" cy="0"/>
+        </a:xfrm>
+      </p:grpSpPr>
       <p:sp>
         <p:nvSpPr>
           <p:cNvPr id="2" name="Rectangle 1"/>
@@ -6099,7 +6240,7 @@
           </a:fontRef>
         </p:style>
         <p:txBody>
-          <a:bodyPr rtlCol="0" anchor="ctr" wrap="square"/>
+          <a:bodyPr wrap="square" rtlCol="0" anchor="ctr"/>
           <a:lstStyle/>
           <a:p>
             <a:pPr algn="l">
@@ -6156,6 +6297,7 @@
           <a:lstStyle/>
           <a:p>
             <a:pPr algn="ctr"/>
+            <a:endParaRPr/>
           </a:p>
         </p:txBody>
       </p:sp>
@@ -6199,6 +6341,7 @@
           <a:lstStyle/>
           <a:p>
             <a:pPr algn="ctr"/>
+            <a:endParaRPr/>
           </a:p>
         </p:txBody>
       </p:sp>
@@ -6242,6 +6385,7 @@
           <a:lstStyle/>
           <a:p>
             <a:pPr algn="ctr"/>
+            <a:endParaRPr/>
           </a:p>
         </p:txBody>
       </p:sp>
@@ -6285,6 +6429,7 @@
           <a:lstStyle/>
           <a:p>
             <a:pPr algn="ctr"/>
+            <a:endParaRPr/>
           </a:p>
         </p:txBody>
       </p:sp>
@@ -6328,6 +6473,7 @@
           <a:lstStyle/>
           <a:p>
             <a:pPr algn="ctr"/>
+            <a:endParaRPr/>
           </a:p>
         </p:txBody>
       </p:sp>
@@ -6380,6 +6526,7 @@
                 <a:latin typeface="Georgia"/>
               </a:defRPr>
             </a:pPr>
+            <a:endParaRPr/>
           </a:p>
           <a:p>
             <a:pPr algn="l">
@@ -6425,6 +6572,7 @@
                 <a:latin typeface="Georgia"/>
               </a:defRPr>
             </a:pPr>
+            <a:endParaRPr/>
           </a:p>
           <a:p>
             <a:pPr algn="l">
@@ -6470,6 +6618,7 @@
                 <a:latin typeface="Georgia"/>
               </a:defRPr>
             </a:pPr>
+            <a:endParaRPr/>
           </a:p>
           <a:p>
             <a:pPr algn="l">
@@ -6515,6 +6664,7 @@
                 <a:latin typeface="Georgia"/>
               </a:defRPr>
             </a:pPr>
+            <a:endParaRPr/>
           </a:p>
           <a:p>
             <a:pPr algn="l">
@@ -6560,6 +6710,7 @@
                 <a:latin typeface="Georgia"/>
               </a:defRPr>
             </a:pPr>
+            <a:endParaRPr/>
           </a:p>
           <a:p>
             <a:pPr algn="l">
@@ -6644,6 +6795,7 @@
                 <a:latin typeface="Georgia"/>
               </a:defRPr>
             </a:pPr>
+            <a:endParaRPr/>
           </a:p>
           <a:p>
             <a:pPr algn="l">
@@ -6705,6 +6857,7 @@
                 <a:latin typeface="Georgia"/>
               </a:defRPr>
             </a:pPr>
+            <a:endParaRPr/>
           </a:p>
           <a:p>
             <a:pPr algn="l">
@@ -6782,6 +6935,7 @@
                 <a:latin typeface="Georgia"/>
               </a:defRPr>
             </a:pPr>
+            <a:endParaRPr/>
           </a:p>
           <a:p>
             <a:pPr algn="l">
@@ -6906,7 +7060,7 @@
 </file>
 
 <file path=ppt/slides/slide15.xml><?xml version="1.0" encoding="utf-8"?>
-<p:sld xmlns:a="http://schemas.openxmlformats.org/drawingml/2006/main" xmlns:p="http://schemas.openxmlformats.org/presentationml/2006/main" xmlns:r="http://schemas.openxmlformats.org/officeDocument/2006/relationships">
+<p:sld xmlns:a="http://schemas.openxmlformats.org/drawingml/2006/main" xmlns:r="http://schemas.openxmlformats.org/officeDocument/2006/relationships" xmlns:p="http://schemas.openxmlformats.org/presentationml/2006/main">
   <p:cSld>
     <p:bg>
       <p:bgPr>
@@ -6922,7 +7076,14 @@
         <p:cNvGrpSpPr/>
         <p:nvPr/>
       </p:nvGrpSpPr>
-      <p:grpSpPr/>
+      <p:grpSpPr>
+        <a:xfrm>
+          <a:off x="0" y="0"/>
+          <a:ext cx="0" cy="0"/>
+          <a:chOff x="0" y="0"/>
+          <a:chExt cx="0" cy="0"/>
+        </a:xfrm>
+      </p:grpSpPr>
       <p:sp>
         <p:nvSpPr>
           <p:cNvPr id="2" name="Rectangle 1"/>
@@ -6959,7 +7120,7 @@
           </a:fontRef>
         </p:style>
         <p:txBody>
-          <a:bodyPr rtlCol="0" anchor="ctr" wrap="square"/>
+          <a:bodyPr wrap="square" rtlCol="0" anchor="ctr"/>
           <a:lstStyle/>
           <a:p>
             <a:pPr algn="l">
@@ -7016,6 +7177,7 @@
           <a:lstStyle/>
           <a:p>
             <a:pPr algn="ctr"/>
+            <a:endParaRPr/>
           </a:p>
         </p:txBody>
       </p:sp>
@@ -7059,6 +7221,7 @@
           <a:lstStyle/>
           <a:p>
             <a:pPr algn="ctr"/>
+            <a:endParaRPr/>
           </a:p>
         </p:txBody>
       </p:sp>
@@ -7102,6 +7265,7 @@
           <a:lstStyle/>
           <a:p>
             <a:pPr algn="ctr"/>
+            <a:endParaRPr/>
           </a:p>
         </p:txBody>
       </p:sp>
@@ -7145,6 +7309,7 @@
           <a:lstStyle/>
           <a:p>
             <a:pPr algn="ctr"/>
+            <a:endParaRPr/>
           </a:p>
         </p:txBody>
       </p:sp>
@@ -7188,6 +7353,7 @@
           <a:lstStyle/>
           <a:p>
             <a:pPr algn="ctr"/>
+            <a:endParaRPr/>
           </a:p>
         </p:txBody>
       </p:sp>
@@ -7240,6 +7406,7 @@
                 <a:latin typeface="Georgia"/>
               </a:defRPr>
             </a:pPr>
+            <a:endParaRPr/>
           </a:p>
           <a:p>
             <a:pPr algn="l">
@@ -7301,6 +7468,7 @@
                 <a:latin typeface="Georgia"/>
               </a:defRPr>
             </a:pPr>
+            <a:endParaRPr/>
           </a:p>
           <a:p>
             <a:pPr algn="l">
@@ -7362,6 +7530,7 @@
                 <a:latin typeface="Georgia"/>
               </a:defRPr>
             </a:pPr>
+            <a:endParaRPr/>
           </a:p>
           <a:p>
             <a:pPr algn="l">
@@ -7423,6 +7592,7 @@
                 <a:latin typeface="Georgia"/>
               </a:defRPr>
             </a:pPr>
+            <a:endParaRPr/>
           </a:p>
           <a:p>
             <a:pPr algn="l">
@@ -7452,6 +7622,7 @@
                 <a:latin typeface="Georgia"/>
               </a:defRPr>
             </a:pPr>
+            <a:endParaRPr/>
           </a:p>
           <a:p>
             <a:pPr algn="l">
@@ -7576,7 +7747,7 @@
 </file>
 
 <file path=ppt/slides/slide16.xml><?xml version="1.0" encoding="utf-8"?>
-<p:sld xmlns:a="http://schemas.openxmlformats.org/drawingml/2006/main" xmlns:p="http://schemas.openxmlformats.org/presentationml/2006/main" xmlns:r="http://schemas.openxmlformats.org/officeDocument/2006/relationships">
+<p:sld xmlns:a="http://schemas.openxmlformats.org/drawingml/2006/main" xmlns:r="http://schemas.openxmlformats.org/officeDocument/2006/relationships" xmlns:p="http://schemas.openxmlformats.org/presentationml/2006/main">
   <p:cSld>
     <p:bg>
       <p:bgPr>
@@ -7592,7 +7763,14 @@
         <p:cNvGrpSpPr/>
         <p:nvPr/>
       </p:nvGrpSpPr>
-      <p:grpSpPr/>
+      <p:grpSpPr>
+        <a:xfrm>
+          <a:off x="0" y="0"/>
+          <a:ext cx="0" cy="0"/>
+          <a:chOff x="0" y="0"/>
+          <a:chExt cx="0" cy="0"/>
+        </a:xfrm>
+      </p:grpSpPr>
       <p:sp>
         <p:nvSpPr>
           <p:cNvPr id="2" name="Rectangle 1"/>
@@ -7629,7 +7807,7 @@
           </a:fontRef>
         </p:style>
         <p:txBody>
-          <a:bodyPr rtlCol="0" anchor="ctr" wrap="square"/>
+          <a:bodyPr wrap="square" rtlCol="0" anchor="ctr"/>
           <a:lstStyle/>
           <a:p>
             <a:pPr algn="l">
@@ -7686,6 +7864,7 @@
           <a:lstStyle/>
           <a:p>
             <a:pPr algn="ctr"/>
+            <a:endParaRPr/>
           </a:p>
         </p:txBody>
       </p:sp>
@@ -7729,6 +7908,7 @@
           <a:lstStyle/>
           <a:p>
             <a:pPr algn="ctr"/>
+            <a:endParaRPr/>
           </a:p>
         </p:txBody>
       </p:sp>
@@ -7772,6 +7952,7 @@
           <a:lstStyle/>
           <a:p>
             <a:pPr algn="ctr"/>
+            <a:endParaRPr/>
           </a:p>
         </p:txBody>
       </p:sp>
@@ -7815,6 +7996,7 @@
           <a:lstStyle/>
           <a:p>
             <a:pPr algn="ctr"/>
+            <a:endParaRPr/>
           </a:p>
         </p:txBody>
       </p:sp>
@@ -7858,6 +8040,7 @@
           <a:lstStyle/>
           <a:p>
             <a:pPr algn="ctr"/>
+            <a:endParaRPr/>
           </a:p>
         </p:txBody>
       </p:sp>
@@ -7910,6 +8093,7 @@
                 <a:latin typeface="Georgia"/>
               </a:defRPr>
             </a:pPr>
+            <a:endParaRPr/>
           </a:p>
           <a:p>
             <a:pPr algn="l">
@@ -7955,6 +8139,7 @@
                 <a:latin typeface="Georgia"/>
               </a:defRPr>
             </a:pPr>
+            <a:endParaRPr/>
           </a:p>
           <a:p>
             <a:pPr algn="l">
@@ -7984,6 +8169,7 @@
                 <a:latin typeface="Georgia"/>
               </a:defRPr>
             </a:pPr>
+            <a:endParaRPr/>
           </a:p>
           <a:p>
             <a:pPr algn="l">
@@ -8013,6 +8199,7 @@
                 <a:latin typeface="Georgia"/>
               </a:defRPr>
             </a:pPr>
+            <a:endParaRPr/>
           </a:p>
           <a:p>
             <a:pPr algn="l">
@@ -8042,6 +8229,7 @@
                 <a:latin typeface="Georgia"/>
               </a:defRPr>
             </a:pPr>
+            <a:endParaRPr/>
           </a:p>
           <a:p>
             <a:pPr algn="l">
@@ -8118,7 +8306,7 @@
 </file>
 
 <file path=ppt/slides/slide17.xml><?xml version="1.0" encoding="utf-8"?>
-<p:sld xmlns:a="http://schemas.openxmlformats.org/drawingml/2006/main" xmlns:p="http://schemas.openxmlformats.org/presentationml/2006/main" xmlns:r="http://schemas.openxmlformats.org/officeDocument/2006/relationships">
+<p:sld xmlns:a="http://schemas.openxmlformats.org/drawingml/2006/main" xmlns:r="http://schemas.openxmlformats.org/officeDocument/2006/relationships" xmlns:p="http://schemas.openxmlformats.org/presentationml/2006/main">
   <p:cSld>
     <p:bg>
       <p:bgPr>
@@ -8134,7 +8322,14 @@
         <p:cNvGrpSpPr/>
         <p:nvPr/>
       </p:nvGrpSpPr>
-      <p:grpSpPr/>
+      <p:grpSpPr>
+        <a:xfrm>
+          <a:off x="0" y="0"/>
+          <a:ext cx="0" cy="0"/>
+          <a:chOff x="0" y="0"/>
+          <a:chExt cx="0" cy="0"/>
+        </a:xfrm>
+      </p:grpSpPr>
       <p:sp>
         <p:nvSpPr>
           <p:cNvPr id="2" name="Rectangle 1"/>
@@ -8175,6 +8370,7 @@
           <a:lstStyle/>
           <a:p>
             <a:pPr algn="ctr"/>
+            <a:endParaRPr/>
           </a:p>
         </p:txBody>
       </p:sp>
@@ -8218,6 +8414,7 @@
           <a:lstStyle/>
           <a:p>
             <a:pPr algn="ctr"/>
+            <a:endParaRPr/>
           </a:p>
         </p:txBody>
       </p:sp>
@@ -8261,6 +8458,7 @@
           <a:lstStyle/>
           <a:p>
             <a:pPr algn="ctr"/>
+            <a:endParaRPr/>
           </a:p>
         </p:txBody>
       </p:sp>
@@ -8304,6 +8502,7 @@
           <a:lstStyle/>
           <a:p>
             <a:pPr algn="ctr"/>
+            <a:endParaRPr/>
           </a:p>
         </p:txBody>
       </p:sp>
@@ -8347,6 +8546,7 @@
           <a:lstStyle/>
           <a:p>
             <a:pPr algn="ctr"/>
+            <a:endParaRPr/>
           </a:p>
         </p:txBody>
       </p:sp>
@@ -8541,6 +8741,7 @@
                 <a:latin typeface="Georgia"/>
               </a:defRPr>
             </a:pPr>
+            <a:endParaRPr/>
           </a:p>
           <a:p>
             <a:pPr algn="l">
@@ -8586,6 +8787,7 @@
                 <a:latin typeface="Georgia"/>
               </a:defRPr>
             </a:pPr>
+            <a:endParaRPr/>
           </a:p>
           <a:p>
             <a:pPr algn="l">
@@ -8678,7 +8880,7 @@
 </file>
 
 <file path=ppt/slides/slide2.xml><?xml version="1.0" encoding="utf-8"?>
-<p:sld xmlns:a="http://schemas.openxmlformats.org/drawingml/2006/main" xmlns:p="http://schemas.openxmlformats.org/presentationml/2006/main" xmlns:r="http://schemas.openxmlformats.org/officeDocument/2006/relationships">
+<p:sld xmlns:a="http://schemas.openxmlformats.org/drawingml/2006/main" xmlns:r="http://schemas.openxmlformats.org/officeDocument/2006/relationships" xmlns:p="http://schemas.openxmlformats.org/presentationml/2006/main">
   <p:cSld>
     <p:bg>
       <p:bgPr>
@@ -8694,7 +8896,14 @@
         <p:cNvGrpSpPr/>
         <p:nvPr/>
       </p:nvGrpSpPr>
-      <p:grpSpPr/>
+      <p:grpSpPr>
+        <a:xfrm>
+          <a:off x="0" y="0"/>
+          <a:ext cx="0" cy="0"/>
+          <a:chOff x="0" y="0"/>
+          <a:chExt cx="0" cy="0"/>
+        </a:xfrm>
+      </p:grpSpPr>
       <p:sp>
         <p:nvSpPr>
           <p:cNvPr id="2" name="Rectangle 1"/>
@@ -8731,7 +8940,7 @@
           </a:fontRef>
         </p:style>
         <p:txBody>
-          <a:bodyPr rtlCol="0" anchor="ctr" wrap="square"/>
+          <a:bodyPr wrap="square" rtlCol="0" anchor="ctr"/>
           <a:lstStyle/>
           <a:p>
             <a:pPr algn="l">
@@ -8788,6 +8997,7 @@
           <a:lstStyle/>
           <a:p>
             <a:pPr algn="ctr"/>
+            <a:endParaRPr/>
           </a:p>
         </p:txBody>
       </p:sp>
@@ -8831,6 +9041,7 @@
           <a:lstStyle/>
           <a:p>
             <a:pPr algn="ctr"/>
+            <a:endParaRPr/>
           </a:p>
         </p:txBody>
       </p:sp>
@@ -8874,6 +9085,7 @@
           <a:lstStyle/>
           <a:p>
             <a:pPr algn="ctr"/>
+            <a:endParaRPr/>
           </a:p>
         </p:txBody>
       </p:sp>
@@ -8917,6 +9129,7 @@
           <a:lstStyle/>
           <a:p>
             <a:pPr algn="ctr"/>
+            <a:endParaRPr/>
           </a:p>
         </p:txBody>
       </p:sp>
@@ -8960,6 +9173,7 @@
           <a:lstStyle/>
           <a:p>
             <a:pPr algn="ctr"/>
+            <a:endParaRPr/>
           </a:p>
         </p:txBody>
       </p:sp>
@@ -9012,6 +9226,7 @@
                 <a:latin typeface="Georgia"/>
               </a:defRPr>
             </a:pPr>
+            <a:endParaRPr/>
           </a:p>
           <a:p>
             <a:pPr algn="l">
@@ -9041,6 +9256,7 @@
                 <a:latin typeface="Georgia"/>
               </a:defRPr>
             </a:pPr>
+            <a:endParaRPr/>
           </a:p>
           <a:p>
             <a:pPr algn="l">
@@ -9070,6 +9286,7 @@
                 <a:latin typeface="Georgia"/>
               </a:defRPr>
             </a:pPr>
+            <a:endParaRPr/>
           </a:p>
           <a:p>
             <a:pPr algn="l">
@@ -9099,6 +9316,7 @@
                 <a:latin typeface="Georgia"/>
               </a:defRPr>
             </a:pPr>
+            <a:endParaRPr/>
           </a:p>
           <a:p>
             <a:pPr algn="l">
@@ -9255,7 +9473,7 @@
 </file>
 
 <file path=ppt/slides/slide3.xml><?xml version="1.0" encoding="utf-8"?>
-<p:sld xmlns:a="http://schemas.openxmlformats.org/drawingml/2006/main" xmlns:p="http://schemas.openxmlformats.org/presentationml/2006/main" xmlns:r="http://schemas.openxmlformats.org/officeDocument/2006/relationships">
+<p:sld xmlns:a="http://schemas.openxmlformats.org/drawingml/2006/main" xmlns:r="http://schemas.openxmlformats.org/officeDocument/2006/relationships" xmlns:p="http://schemas.openxmlformats.org/presentationml/2006/main">
   <p:cSld>
     <p:bg>
       <p:bgPr>
@@ -9271,7 +9489,14 @@
         <p:cNvGrpSpPr/>
         <p:nvPr/>
       </p:nvGrpSpPr>
-      <p:grpSpPr/>
+      <p:grpSpPr>
+        <a:xfrm>
+          <a:off x="0" y="0"/>
+          <a:ext cx="0" cy="0"/>
+          <a:chOff x="0" y="0"/>
+          <a:chExt cx="0" cy="0"/>
+        </a:xfrm>
+      </p:grpSpPr>
       <p:sp>
         <p:nvSpPr>
           <p:cNvPr id="2" name="Rectangle 1"/>
@@ -9308,7 +9533,7 @@
           </a:fontRef>
         </p:style>
         <p:txBody>
-          <a:bodyPr rtlCol="0" anchor="ctr" wrap="square"/>
+          <a:bodyPr wrap="square" rtlCol="0" anchor="ctr"/>
           <a:lstStyle/>
           <a:p>
             <a:pPr algn="l">
@@ -9365,6 +9590,7 @@
           <a:lstStyle/>
           <a:p>
             <a:pPr algn="ctr"/>
+            <a:endParaRPr/>
           </a:p>
         </p:txBody>
       </p:sp>
@@ -9408,6 +9634,7 @@
           <a:lstStyle/>
           <a:p>
             <a:pPr algn="ctr"/>
+            <a:endParaRPr/>
           </a:p>
         </p:txBody>
       </p:sp>
@@ -9451,6 +9678,7 @@
           <a:lstStyle/>
           <a:p>
             <a:pPr algn="ctr"/>
+            <a:endParaRPr/>
           </a:p>
         </p:txBody>
       </p:sp>
@@ -9494,6 +9722,7 @@
           <a:lstStyle/>
           <a:p>
             <a:pPr algn="ctr"/>
+            <a:endParaRPr/>
           </a:p>
         </p:txBody>
       </p:sp>
@@ -9537,6 +9766,7 @@
           <a:lstStyle/>
           <a:p>
             <a:pPr algn="ctr"/>
+            <a:endParaRPr/>
           </a:p>
         </p:txBody>
       </p:sp>
@@ -9589,6 +9819,7 @@
                 <a:latin typeface="Georgia"/>
               </a:defRPr>
             </a:pPr>
+            <a:endParaRPr/>
           </a:p>
           <a:p>
             <a:pPr algn="l">
@@ -9634,6 +9865,7 @@
                 <a:latin typeface="Georgia"/>
               </a:defRPr>
             </a:pPr>
+            <a:endParaRPr/>
           </a:p>
           <a:p>
             <a:pPr algn="l">
@@ -9711,6 +9943,7 @@
                 <a:latin typeface="Georgia"/>
               </a:defRPr>
             </a:pPr>
+            <a:endParaRPr/>
           </a:p>
           <a:p>
             <a:pPr algn="l">
@@ -9851,7 +10084,7 @@
 </file>
 
 <file path=ppt/slides/slide4.xml><?xml version="1.0" encoding="utf-8"?>
-<p:sld xmlns:a="http://schemas.openxmlformats.org/drawingml/2006/main" xmlns:p="http://schemas.openxmlformats.org/presentationml/2006/main" xmlns:r="http://schemas.openxmlformats.org/officeDocument/2006/relationships">
+<p:sld xmlns:a="http://schemas.openxmlformats.org/drawingml/2006/main" xmlns:r="http://schemas.openxmlformats.org/officeDocument/2006/relationships" xmlns:p="http://schemas.openxmlformats.org/presentationml/2006/main">
   <p:cSld>
     <p:bg>
       <p:bgPr>
@@ -9867,7 +10100,14 @@
         <p:cNvGrpSpPr/>
         <p:nvPr/>
       </p:nvGrpSpPr>
-      <p:grpSpPr/>
+      <p:grpSpPr>
+        <a:xfrm>
+          <a:off x="0" y="0"/>
+          <a:ext cx="0" cy="0"/>
+          <a:chOff x="0" y="0"/>
+          <a:chExt cx="0" cy="0"/>
+        </a:xfrm>
+      </p:grpSpPr>
       <p:sp>
         <p:nvSpPr>
           <p:cNvPr id="2" name="Rectangle 1"/>
@@ -9876,8 +10116,8 @@
         </p:nvSpPr>
         <p:spPr>
           <a:xfrm>
-            <a:off x="0" y="30000"/>
-            <a:ext cx="5500000" cy="470000"/>
+            <a:off x="0" y="33000"/>
+            <a:ext cx="6032938" cy="470000"/>
           </a:xfrm>
           <a:prstGeom prst="rect">
             <a:avLst/>
@@ -9904,7 +10144,7 @@
           </a:fontRef>
         </p:style>
         <p:txBody>
-          <a:bodyPr rtlCol="0" anchor="ctr" wrap="square"/>
+          <a:bodyPr wrap="square" rtlCol="0" anchor="ctr"/>
           <a:lstStyle/>
           <a:p>
             <a:pPr algn="l">
@@ -9916,8 +10156,22 @@
               </a:defRPr>
             </a:pPr>
             <a:r>
-              <a:t>  Технологичность стартап-проекта</a:t>
-            </a:r>
+              <a:rPr dirty="0"/>
+              <a:t>  </a:t>
+            </a:r>
+            <a:r>
+              <a:rPr dirty="0" err="1"/>
+              <a:t>Технологичность</a:t>
+            </a:r>
+            <a:r>
+              <a:rPr dirty="0"/>
+              <a:t> </a:t>
+            </a:r>
+            <a:r>
+              <a:rPr dirty="0" err="1"/>
+              <a:t>стартап-проекта</a:t>
+            </a:r>
+            <a:endParaRPr dirty="0"/>
           </a:p>
         </p:txBody>
       </p:sp>
@@ -9961,6 +10215,7 @@
           <a:lstStyle/>
           <a:p>
             <a:pPr algn="ctr"/>
+            <a:endParaRPr/>
           </a:p>
         </p:txBody>
       </p:sp>
@@ -10004,6 +10259,7 @@
           <a:lstStyle/>
           <a:p>
             <a:pPr algn="ctr"/>
+            <a:endParaRPr/>
           </a:p>
         </p:txBody>
       </p:sp>
@@ -10047,6 +10303,7 @@
           <a:lstStyle/>
           <a:p>
             <a:pPr algn="ctr"/>
+            <a:endParaRPr/>
           </a:p>
         </p:txBody>
       </p:sp>
@@ -10090,6 +10347,7 @@
           <a:lstStyle/>
           <a:p>
             <a:pPr algn="ctr"/>
+            <a:endParaRPr/>
           </a:p>
         </p:txBody>
       </p:sp>
@@ -10133,6 +10391,7 @@
           <a:lstStyle/>
           <a:p>
             <a:pPr algn="ctr"/>
+            <a:endParaRPr/>
           </a:p>
         </p:txBody>
       </p:sp>
@@ -10185,6 +10444,7 @@
                 <a:latin typeface="Georgia"/>
               </a:defRPr>
             </a:pPr>
+            <a:endParaRPr/>
           </a:p>
           <a:p>
             <a:pPr algn="l">
@@ -10278,6 +10538,7 @@
                 <a:latin typeface="Georgia"/>
               </a:defRPr>
             </a:pPr>
+            <a:endParaRPr/>
           </a:p>
           <a:p>
             <a:pPr algn="l">
@@ -10370,7 +10631,7 @@
 </file>
 
 <file path=ppt/slides/slide5.xml><?xml version="1.0" encoding="utf-8"?>
-<p:sld xmlns:a="http://schemas.openxmlformats.org/drawingml/2006/main" xmlns:p="http://schemas.openxmlformats.org/presentationml/2006/main" xmlns:r="http://schemas.openxmlformats.org/officeDocument/2006/relationships">
+<p:sld xmlns:a="http://schemas.openxmlformats.org/drawingml/2006/main" xmlns:r="http://schemas.openxmlformats.org/officeDocument/2006/relationships" xmlns:p="http://schemas.openxmlformats.org/presentationml/2006/main">
   <p:cSld>
     <p:bg>
       <p:bgPr>
@@ -10386,7 +10647,14 @@
         <p:cNvGrpSpPr/>
         <p:nvPr/>
       </p:nvGrpSpPr>
-      <p:grpSpPr/>
+      <p:grpSpPr>
+        <a:xfrm>
+          <a:off x="0" y="0"/>
+          <a:ext cx="0" cy="0"/>
+          <a:chOff x="0" y="0"/>
+          <a:chExt cx="0" cy="0"/>
+        </a:xfrm>
+      </p:grpSpPr>
       <p:sp>
         <p:nvSpPr>
           <p:cNvPr id="2" name="Rectangle 1"/>
@@ -10395,8 +10663,8 @@
         </p:nvSpPr>
         <p:spPr>
           <a:xfrm>
-            <a:off x="0" y="30000"/>
-            <a:ext cx="5500000" cy="470000"/>
+            <a:off x="-1" y="33000"/>
+            <a:ext cx="6011917" cy="470000"/>
           </a:xfrm>
           <a:prstGeom prst="rect">
             <a:avLst/>
@@ -10423,7 +10691,7 @@
           </a:fontRef>
         </p:style>
         <p:txBody>
-          <a:bodyPr rtlCol="0" anchor="ctr" wrap="square"/>
+          <a:bodyPr wrap="square" rtlCol="0" anchor="ctr"/>
           <a:lstStyle/>
           <a:p>
             <a:pPr algn="l">
@@ -10480,6 +10748,7 @@
           <a:lstStyle/>
           <a:p>
             <a:pPr algn="ctr"/>
+            <a:endParaRPr/>
           </a:p>
         </p:txBody>
       </p:sp>
@@ -10523,6 +10792,7 @@
           <a:lstStyle/>
           <a:p>
             <a:pPr algn="ctr"/>
+            <a:endParaRPr/>
           </a:p>
         </p:txBody>
       </p:sp>
@@ -10566,6 +10836,7 @@
           <a:lstStyle/>
           <a:p>
             <a:pPr algn="ctr"/>
+            <a:endParaRPr/>
           </a:p>
         </p:txBody>
       </p:sp>
@@ -10609,6 +10880,7 @@
           <a:lstStyle/>
           <a:p>
             <a:pPr algn="ctr"/>
+            <a:endParaRPr/>
           </a:p>
         </p:txBody>
       </p:sp>
@@ -10652,6 +10924,7 @@
           <a:lstStyle/>
           <a:p>
             <a:pPr algn="ctr"/>
+            <a:endParaRPr/>
           </a:p>
         </p:txBody>
       </p:sp>
@@ -10704,6 +10977,7 @@
                 <a:latin typeface="Georgia"/>
               </a:defRPr>
             </a:pPr>
+            <a:endParaRPr/>
           </a:p>
           <a:p>
             <a:pPr algn="l">
@@ -10733,6 +11007,7 @@
                 <a:latin typeface="Georgia"/>
               </a:defRPr>
             </a:pPr>
+            <a:endParaRPr/>
           </a:p>
           <a:p>
             <a:pPr algn="l">
@@ -10762,6 +11037,7 @@
                 <a:latin typeface="Georgia"/>
               </a:defRPr>
             </a:pPr>
+            <a:endParaRPr/>
           </a:p>
           <a:p>
             <a:pPr algn="l">
@@ -10791,6 +11067,7 @@
                 <a:latin typeface="Georgia"/>
               </a:defRPr>
             </a:pPr>
+            <a:endParaRPr/>
           </a:p>
           <a:p>
             <a:pPr algn="l">
@@ -10820,6 +11097,7 @@
                 <a:latin typeface="Georgia"/>
               </a:defRPr>
             </a:pPr>
+            <a:endParaRPr/>
           </a:p>
           <a:p>
             <a:pPr algn="l">
@@ -10896,7 +11174,7 @@
 </file>
 
 <file path=ppt/slides/slide6.xml><?xml version="1.0" encoding="utf-8"?>
-<p:sld xmlns:a="http://schemas.openxmlformats.org/drawingml/2006/main" xmlns:p="http://schemas.openxmlformats.org/presentationml/2006/main" xmlns:r="http://schemas.openxmlformats.org/officeDocument/2006/relationships">
+<p:sld xmlns:a="http://schemas.openxmlformats.org/drawingml/2006/main" xmlns:r="http://schemas.openxmlformats.org/officeDocument/2006/relationships" xmlns:p="http://schemas.openxmlformats.org/presentationml/2006/main">
   <p:cSld>
     <p:bg>
       <p:bgPr>
@@ -10912,7 +11190,14 @@
         <p:cNvGrpSpPr/>
         <p:nvPr/>
       </p:nvGrpSpPr>
-      <p:grpSpPr/>
+      <p:grpSpPr>
+        <a:xfrm>
+          <a:off x="0" y="0"/>
+          <a:ext cx="0" cy="0"/>
+          <a:chOff x="0" y="0"/>
+          <a:chExt cx="0" cy="0"/>
+        </a:xfrm>
+      </p:grpSpPr>
       <p:sp>
         <p:nvSpPr>
           <p:cNvPr id="2" name="Rectangle 1"/>
@@ -10949,7 +11234,7 @@
           </a:fontRef>
         </p:style>
         <p:txBody>
-          <a:bodyPr rtlCol="0" anchor="ctr" wrap="square"/>
+          <a:bodyPr wrap="square" rtlCol="0" anchor="ctr"/>
           <a:lstStyle/>
           <a:p>
             <a:pPr algn="l">
@@ -11006,6 +11291,7 @@
           <a:lstStyle/>
           <a:p>
             <a:pPr algn="ctr"/>
+            <a:endParaRPr/>
           </a:p>
         </p:txBody>
       </p:sp>
@@ -11049,6 +11335,7 @@
           <a:lstStyle/>
           <a:p>
             <a:pPr algn="ctr"/>
+            <a:endParaRPr/>
           </a:p>
         </p:txBody>
       </p:sp>
@@ -11092,6 +11379,7 @@
           <a:lstStyle/>
           <a:p>
             <a:pPr algn="ctr"/>
+            <a:endParaRPr/>
           </a:p>
         </p:txBody>
       </p:sp>
@@ -11135,6 +11423,7 @@
           <a:lstStyle/>
           <a:p>
             <a:pPr algn="ctr"/>
+            <a:endParaRPr/>
           </a:p>
         </p:txBody>
       </p:sp>
@@ -11178,6 +11467,7 @@
           <a:lstStyle/>
           <a:p>
             <a:pPr algn="ctr"/>
+            <a:endParaRPr/>
           </a:p>
         </p:txBody>
       </p:sp>
@@ -11230,6 +11520,7 @@
                 <a:latin typeface="Georgia"/>
               </a:defRPr>
             </a:pPr>
+            <a:endParaRPr/>
           </a:p>
           <a:p>
             <a:pPr algn="l">
@@ -11339,6 +11630,7 @@
                 <a:latin typeface="Georgia"/>
               </a:defRPr>
             </a:pPr>
+            <a:endParaRPr/>
           </a:p>
           <a:p>
             <a:pPr algn="l">
@@ -11495,7 +11787,7 @@
 </file>
 
 <file path=ppt/slides/slide7.xml><?xml version="1.0" encoding="utf-8"?>
-<p:sld xmlns:a="http://schemas.openxmlformats.org/drawingml/2006/main" xmlns:p="http://schemas.openxmlformats.org/presentationml/2006/main" xmlns:r="http://schemas.openxmlformats.org/officeDocument/2006/relationships">
+<p:sld xmlns:a="http://schemas.openxmlformats.org/drawingml/2006/main" xmlns:r="http://schemas.openxmlformats.org/officeDocument/2006/relationships" xmlns:p="http://schemas.openxmlformats.org/presentationml/2006/main">
   <p:cSld>
     <p:bg>
       <p:bgPr>
@@ -11511,7 +11803,14 @@
         <p:cNvGrpSpPr/>
         <p:nvPr/>
       </p:nvGrpSpPr>
-      <p:grpSpPr/>
+      <p:grpSpPr>
+        <a:xfrm>
+          <a:off x="0" y="0"/>
+          <a:ext cx="0" cy="0"/>
+          <a:chOff x="0" y="0"/>
+          <a:chExt cx="0" cy="0"/>
+        </a:xfrm>
+      </p:grpSpPr>
       <p:sp>
         <p:nvSpPr>
           <p:cNvPr id="2" name="Rectangle 1"/>
@@ -11548,7 +11847,7 @@
           </a:fontRef>
         </p:style>
         <p:txBody>
-          <a:bodyPr rtlCol="0" anchor="ctr" wrap="square"/>
+          <a:bodyPr wrap="square" rtlCol="0" anchor="ctr"/>
           <a:lstStyle/>
           <a:p>
             <a:pPr algn="l">
@@ -11605,6 +11904,7 @@
           <a:lstStyle/>
           <a:p>
             <a:pPr algn="ctr"/>
+            <a:endParaRPr/>
           </a:p>
         </p:txBody>
       </p:sp>
@@ -11648,6 +11948,7 @@
           <a:lstStyle/>
           <a:p>
             <a:pPr algn="ctr"/>
+            <a:endParaRPr/>
           </a:p>
         </p:txBody>
       </p:sp>
@@ -11691,6 +11992,7 @@
           <a:lstStyle/>
           <a:p>
             <a:pPr algn="ctr"/>
+            <a:endParaRPr/>
           </a:p>
         </p:txBody>
       </p:sp>
@@ -11734,6 +12036,7 @@
           <a:lstStyle/>
           <a:p>
             <a:pPr algn="ctr"/>
+            <a:endParaRPr/>
           </a:p>
         </p:txBody>
       </p:sp>
@@ -11777,6 +12080,7 @@
           <a:lstStyle/>
           <a:p>
             <a:pPr algn="ctr"/>
+            <a:endParaRPr/>
           </a:p>
         </p:txBody>
       </p:sp>
@@ -11829,6 +12133,7 @@
                 <a:latin typeface="Georgia"/>
               </a:defRPr>
             </a:pPr>
+            <a:endParaRPr/>
           </a:p>
           <a:p>
             <a:pPr algn="l">
@@ -11906,6 +12211,7 @@
                 <a:latin typeface="Georgia"/>
               </a:defRPr>
             </a:pPr>
+            <a:endParaRPr/>
           </a:p>
           <a:p>
             <a:pPr algn="l">
@@ -11935,6 +12241,7 @@
                 <a:latin typeface="Georgia"/>
               </a:defRPr>
             </a:pPr>
+            <a:endParaRPr/>
           </a:p>
           <a:p>
             <a:pPr algn="l">
@@ -12027,7 +12334,7 @@
 </file>
 
 <file path=ppt/slides/slide8.xml><?xml version="1.0" encoding="utf-8"?>
-<p:sld xmlns:a="http://schemas.openxmlformats.org/drawingml/2006/main" xmlns:p="http://schemas.openxmlformats.org/presentationml/2006/main" xmlns:r="http://schemas.openxmlformats.org/officeDocument/2006/relationships">
+<p:sld xmlns:a="http://schemas.openxmlformats.org/drawingml/2006/main" xmlns:r="http://schemas.openxmlformats.org/officeDocument/2006/relationships" xmlns:p="http://schemas.openxmlformats.org/presentationml/2006/main">
   <p:cSld>
     <p:bg>
       <p:bgPr>
@@ -12043,7 +12350,14 @@
         <p:cNvGrpSpPr/>
         <p:nvPr/>
       </p:nvGrpSpPr>
-      <p:grpSpPr/>
+      <p:grpSpPr>
+        <a:xfrm>
+          <a:off x="0" y="0"/>
+          <a:ext cx="0" cy="0"/>
+          <a:chOff x="0" y="0"/>
+          <a:chExt cx="0" cy="0"/>
+        </a:xfrm>
+      </p:grpSpPr>
       <p:sp>
         <p:nvSpPr>
           <p:cNvPr id="2" name="Rectangle 1"/>
@@ -12080,7 +12394,7 @@
           </a:fontRef>
         </p:style>
         <p:txBody>
-          <a:bodyPr rtlCol="0" anchor="ctr" wrap="square"/>
+          <a:bodyPr wrap="square" rtlCol="0" anchor="ctr"/>
           <a:lstStyle/>
           <a:p>
             <a:pPr algn="l">
@@ -12137,6 +12451,7 @@
           <a:lstStyle/>
           <a:p>
             <a:pPr algn="ctr"/>
+            <a:endParaRPr/>
           </a:p>
         </p:txBody>
       </p:sp>
@@ -12180,6 +12495,7 @@
           <a:lstStyle/>
           <a:p>
             <a:pPr algn="ctr"/>
+            <a:endParaRPr/>
           </a:p>
         </p:txBody>
       </p:sp>
@@ -12223,6 +12539,7 @@
           <a:lstStyle/>
           <a:p>
             <a:pPr algn="ctr"/>
+            <a:endParaRPr/>
           </a:p>
         </p:txBody>
       </p:sp>
@@ -12266,6 +12583,7 @@
           <a:lstStyle/>
           <a:p>
             <a:pPr algn="ctr"/>
+            <a:endParaRPr/>
           </a:p>
         </p:txBody>
       </p:sp>
@@ -12309,6 +12627,7 @@
           <a:lstStyle/>
           <a:p>
             <a:pPr algn="ctr"/>
+            <a:endParaRPr/>
           </a:p>
         </p:txBody>
       </p:sp>
@@ -12361,6 +12680,7 @@
                 <a:latin typeface="Georgia"/>
               </a:defRPr>
             </a:pPr>
+            <a:endParaRPr/>
           </a:p>
           <a:p>
             <a:pPr algn="l">
@@ -12390,6 +12710,7 @@
                 <a:latin typeface="Georgia"/>
               </a:defRPr>
             </a:pPr>
+            <a:endParaRPr/>
           </a:p>
           <a:p>
             <a:pPr algn="l">
@@ -12419,6 +12740,7 @@
                 <a:latin typeface="Georgia"/>
               </a:defRPr>
             </a:pPr>
+            <a:endParaRPr/>
           </a:p>
           <a:p>
             <a:pPr algn="l">
@@ -12448,6 +12770,7 @@
                 <a:latin typeface="Georgia"/>
               </a:defRPr>
             </a:pPr>
+            <a:endParaRPr/>
           </a:p>
           <a:p>
             <a:pPr algn="l">
@@ -12477,6 +12800,7 @@
                 <a:latin typeface="Georgia"/>
               </a:defRPr>
             </a:pPr>
+            <a:endParaRPr/>
           </a:p>
           <a:p>
             <a:pPr algn="l">
@@ -12553,7 +12877,7 @@
 </file>
 
 <file path=ppt/slides/slide9.xml><?xml version="1.0" encoding="utf-8"?>
-<p:sld xmlns:a="http://schemas.openxmlformats.org/drawingml/2006/main" xmlns:p="http://schemas.openxmlformats.org/presentationml/2006/main" xmlns:r="http://schemas.openxmlformats.org/officeDocument/2006/relationships">
+<p:sld xmlns:a="http://schemas.openxmlformats.org/drawingml/2006/main" xmlns:r="http://schemas.openxmlformats.org/officeDocument/2006/relationships" xmlns:p="http://schemas.openxmlformats.org/presentationml/2006/main">
   <p:cSld>
     <p:bg>
       <p:bgPr>
@@ -12569,7 +12893,14 @@
         <p:cNvGrpSpPr/>
         <p:nvPr/>
       </p:nvGrpSpPr>
-      <p:grpSpPr/>
+      <p:grpSpPr>
+        <a:xfrm>
+          <a:off x="0" y="0"/>
+          <a:ext cx="0" cy="0"/>
+          <a:chOff x="0" y="0"/>
+          <a:chExt cx="0" cy="0"/>
+        </a:xfrm>
+      </p:grpSpPr>
       <p:sp>
         <p:nvSpPr>
           <p:cNvPr id="2" name="Rectangle 1"/>
@@ -12606,7 +12937,7 @@
           </a:fontRef>
         </p:style>
         <p:txBody>
-          <a:bodyPr rtlCol="0" anchor="ctr" wrap="square"/>
+          <a:bodyPr wrap="square" rtlCol="0" anchor="ctr"/>
           <a:lstStyle/>
           <a:p>
             <a:pPr algn="l">
@@ -12663,6 +12994,7 @@
           <a:lstStyle/>
           <a:p>
             <a:pPr algn="ctr"/>
+            <a:endParaRPr/>
           </a:p>
         </p:txBody>
       </p:sp>
@@ -12706,6 +13038,7 @@
           <a:lstStyle/>
           <a:p>
             <a:pPr algn="ctr"/>
+            <a:endParaRPr/>
           </a:p>
         </p:txBody>
       </p:sp>
@@ -12749,6 +13082,7 @@
           <a:lstStyle/>
           <a:p>
             <a:pPr algn="ctr"/>
+            <a:endParaRPr/>
           </a:p>
         </p:txBody>
       </p:sp>
@@ -12792,6 +13126,7 @@
           <a:lstStyle/>
           <a:p>
             <a:pPr algn="ctr"/>
+            <a:endParaRPr/>
           </a:p>
         </p:txBody>
       </p:sp>
@@ -12835,6 +13170,7 @@
           <a:lstStyle/>
           <a:p>
             <a:pPr algn="ctr"/>
+            <a:endParaRPr/>
           </a:p>
         </p:txBody>
       </p:sp>
@@ -12896,11 +13232,41 @@
                 <a:tableStyleId>{5C22544A-7EE6-4342-B048-85BDC9FD1C3A}</a:tableStyleId>
               </a:tblPr>
               <a:tblGrid>
-                <a:gridCol w="1640000"/>
-                <a:gridCol w="1640000"/>
-                <a:gridCol w="1640000"/>
-                <a:gridCol w="1640000"/>
-                <a:gridCol w="1640000"/>
+                <a:gridCol w="1640000">
+                  <a:extLst>
+                    <a:ext uri="{9D8B030D-6E8A-4147-A177-3AD203B41FA5}">
+                      <a16:colId xmlns:a16="http://schemas.microsoft.com/office/drawing/2014/main" val="20000"/>
+                    </a:ext>
+                  </a:extLst>
+                </a:gridCol>
+                <a:gridCol w="1640000">
+                  <a:extLst>
+                    <a:ext uri="{9D8B030D-6E8A-4147-A177-3AD203B41FA5}">
+                      <a16:colId xmlns:a16="http://schemas.microsoft.com/office/drawing/2014/main" val="20001"/>
+                    </a:ext>
+                  </a:extLst>
+                </a:gridCol>
+                <a:gridCol w="1640000">
+                  <a:extLst>
+                    <a:ext uri="{9D8B030D-6E8A-4147-A177-3AD203B41FA5}">
+                      <a16:colId xmlns:a16="http://schemas.microsoft.com/office/drawing/2014/main" val="20002"/>
+                    </a:ext>
+                  </a:extLst>
+                </a:gridCol>
+                <a:gridCol w="1640000">
+                  <a:extLst>
+                    <a:ext uri="{9D8B030D-6E8A-4147-A177-3AD203B41FA5}">
+                      <a16:colId xmlns:a16="http://schemas.microsoft.com/office/drawing/2014/main" val="20003"/>
+                    </a:ext>
+                  </a:extLst>
+                </a:gridCol>
+                <a:gridCol w="1640000">
+                  <a:extLst>
+                    <a:ext uri="{9D8B030D-6E8A-4147-A177-3AD203B41FA5}">
+                      <a16:colId xmlns:a16="http://schemas.microsoft.com/office/drawing/2014/main" val="20004"/>
+                    </a:ext>
+                  </a:extLst>
+                </a:gridCol>
               </a:tblGrid>
               <a:tr h="533333">
                 <a:tc>
@@ -13023,6 +13389,11 @@
                     </a:solidFill>
                   </a:tcPr>
                 </a:tc>
+                <a:extLst>
+                  <a:ext uri="{0D108BD9-81ED-4DB2-BD59-A6C34878D82A}">
+                    <a16:rowId xmlns:a16="http://schemas.microsoft.com/office/drawing/2014/main" val="10000"/>
+                  </a:ext>
+                </a:extLst>
               </a:tr>
               <a:tr h="533333">
                 <a:tc>
@@ -13125,6 +13496,11 @@
                   </a:txBody>
                   <a:tcPr/>
                 </a:tc>
+                <a:extLst>
+                  <a:ext uri="{0D108BD9-81ED-4DB2-BD59-A6C34878D82A}">
+                    <a16:rowId xmlns:a16="http://schemas.microsoft.com/office/drawing/2014/main" val="10001"/>
+                  </a:ext>
+                </a:extLst>
               </a:tr>
               <a:tr h="533333">
                 <a:tc>
@@ -13227,6 +13603,11 @@
                   </a:txBody>
                   <a:tcPr/>
                 </a:tc>
+                <a:extLst>
+                  <a:ext uri="{0D108BD9-81ED-4DB2-BD59-A6C34878D82A}">
+                    <a16:rowId xmlns:a16="http://schemas.microsoft.com/office/drawing/2014/main" val="10002"/>
+                  </a:ext>
+                </a:extLst>
               </a:tr>
               <a:tr h="533333">
                 <a:tc>
@@ -13329,6 +13710,11 @@
                   </a:txBody>
                   <a:tcPr/>
                 </a:tc>
+                <a:extLst>
+                  <a:ext uri="{0D108BD9-81ED-4DB2-BD59-A6C34878D82A}">
+                    <a16:rowId xmlns:a16="http://schemas.microsoft.com/office/drawing/2014/main" val="10003"/>
+                  </a:ext>
+                </a:extLst>
               </a:tr>
               <a:tr h="533333">
                 <a:tc>
@@ -13431,6 +13817,11 @@
                   </a:txBody>
                   <a:tcPr/>
                 </a:tc>
+                <a:extLst>
+                  <a:ext uri="{0D108BD9-81ED-4DB2-BD59-A6C34878D82A}">
+                    <a16:rowId xmlns:a16="http://schemas.microsoft.com/office/drawing/2014/main" val="10004"/>
+                  </a:ext>
+                </a:extLst>
               </a:tr>
               <a:tr h="533335">
                 <a:tc>
@@ -13533,6 +13924,11 @@
                   </a:txBody>
                   <a:tcPr/>
                 </a:tc>
+                <a:extLst>
+                  <a:ext uri="{0D108BD9-81ED-4DB2-BD59-A6C34878D82A}">
+                    <a16:rowId xmlns:a16="http://schemas.microsoft.com/office/drawing/2014/main" val="10005"/>
+                  </a:ext>
+                </a:extLst>
               </a:tr>
             </a:tbl>
           </a:graphicData>

</xml_diff>